<commit_message>
feat: add the group-products house beside Mega5G
Place Дом групповых продуктов on the Telecom direction, metrics, and Q3 result slides, and add a demo slide for the three MegaFamily screens. 2027 migrations stay off the Q4 plan.

Co-authored-by: bbenicore <bbenicore@gmail.com>
</commit_message>
<xml_diff>
--- a/presentations/Квартальное_демо_Телеком_19.10.2026.pptx
+++ b/presentations/Квартальное_демо_Телеком_19.10.2026.pptx
@@ -13,6 +13,7 @@
     <p:sldId id="257" r:id="rId4"/>
     <p:sldId id="259" r:id="rId5"/>
     <p:sldId id="260" r:id="rId6"/>
+    <p:sldId id="272" r:id="rId21"/>
     <p:sldId id="261" r:id="rId7"/>
     <p:sldId id="262" r:id="rId8"/>
     <p:sldId id="271" r:id="rId9"/>
@@ -3847,6 +3848,1425 @@
       </p:grpSpPr>
       <p:sp>
         <p:nvSpPr>
+          <p:cNvPr id="18" name="section">
+            <a:extLst>
+              <a:ext uri="{FF2B5EF4-FFF2-40B4-BE49-F238E27FC236}">
+                <a16:creationId xmlns:a16="http://schemas.microsoft.com/office/drawing/2014/main" id="{61FB8580-4ADC-4C1E-B3FC-0D72A5508B0D}"/>
+              </a:ext>
+            </a:extLst>
+          </p:cNvPr>
+          <p:cNvSpPr>
+            <a:spLocks noGrp="1"/>
+          </p:cNvSpPr>
+          <p:nvPr/>
+        </p:nvSpPr>
+        <p:spPr>
+          <a:xfrm>
+            <a:off x="457200" y="257175"/>
+            <a:ext cx="7572375" cy="209550"/>
+          </a:xfrm>
+          <a:prstGeom prst="rect">
+            <a:avLst/>
+          </a:prstGeom>
+          <a:noFill/>
+          <a:ln w="0">
+            <a:noFill/>
+          </a:ln>
+        </p:spPr>
+        <p:txBody>
+          <a:bodyPr wrap="square" lIns="0" tIns="0" rIns="0" bIns="0" anchor="t">
+            <a:noAutofit/>
+          </a:bodyPr>
+          <a:lstStyle/>
+          <a:p>
+            <a:pPr algn="l">
+              <a:defRPr sz="900" b="1">
+                <a:solidFill>
+                  <a:srgbClr val="731982"/>
+                </a:solidFill>
+                <a:latin typeface="Helvetica Neue"/>
+                <a:ea typeface="Helvetica Neue"/>
+                <a:cs typeface="Helvetica Neue"/>
+              </a:defRPr>
+            </a:pPr>
+            <a:r>
+              <a:rPr sz="900" b="1">
+                <a:solidFill>
+                  <a:srgbClr val="731982"/>
+                </a:solidFill>
+                <a:latin typeface="Helvetica Neue"/>
+                <a:ea typeface="Helvetica Neue"/>
+                <a:cs typeface="Helvetica Neue"/>
+              </a:rPr>
+              <a:t>Бэкап · Пример к шаблону 02</a:t>
+            </a:r>
+          </a:p>
+        </p:txBody>
+      </p:sp>
+      <p:sp>
+        <p:nvSpPr>
+          <p:cNvPr id="2" name="context">
+            <a:extLst>
+              <a:ext uri="{FF2B5EF4-FFF2-40B4-BE49-F238E27FC236}">
+                <a16:creationId xmlns:a16="http://schemas.microsoft.com/office/drawing/2014/main" id="{74873236-E01F-4863-8FD0-76214759F244}"/>
+              </a:ext>
+            </a:extLst>
+          </p:cNvPr>
+          <p:cNvSpPr>
+            <a:spLocks noGrp="1"/>
+          </p:cNvSpPr>
+          <p:nvPr/>
+        </p:nvSpPr>
+        <p:spPr>
+          <a:xfrm>
+            <a:off x="8058150" y="257175"/>
+            <a:ext cx="3676650" cy="228600"/>
+          </a:xfrm>
+          <a:prstGeom prst="rect">
+            <a:avLst/>
+          </a:prstGeom>
+          <a:noFill/>
+          <a:ln w="0">
+            <a:noFill/>
+          </a:ln>
+        </p:spPr>
+        <p:txBody>
+          <a:bodyPr wrap="square" lIns="0" tIns="0" rIns="0" bIns="0" anchor="t">
+            <a:noAutofit/>
+          </a:bodyPr>
+          <a:lstStyle/>
+          <a:p>
+            <a:pPr algn="r">
+              <a:defRPr sz="900" b="1">
+                <a:solidFill>
+                  <a:srgbClr val="731982"/>
+                </a:solidFill>
+                <a:latin typeface="Helvetica Neue"/>
+                <a:ea typeface="Helvetica Neue"/>
+                <a:cs typeface="Helvetica Neue"/>
+              </a:defRPr>
+            </a:pPr>
+            <a:r>
+              <a:rPr sz="900" b="1">
+                <a:solidFill>
+                  <a:srgbClr val="731982"/>
+                </a:solidFill>
+                <a:latin typeface="Helvetica Neue"/>
+                <a:ea typeface="Helvetica Neue"/>
+                <a:cs typeface="Helvetica Neue"/>
+              </a:rPr>
+              <a:t>Условный пример</a:t>
+            </a:r>
+          </a:p>
+        </p:txBody>
+      </p:sp>
+      <p:sp>
+        <p:nvSpPr>
+          <p:cNvPr id="3" name="title">
+            <a:extLst>
+              <a:ext uri="{FF2B5EF4-FFF2-40B4-BE49-F238E27FC236}">
+                <a16:creationId xmlns:a16="http://schemas.microsoft.com/office/drawing/2014/main" id="{AC701059-1651-4803-9C35-986C4D0DFB84}"/>
+              </a:ext>
+            </a:extLst>
+          </p:cNvPr>
+          <p:cNvSpPr>
+            <a:spLocks noGrp="1"/>
+          </p:cNvSpPr>
+          <p:nvPr/>
+        </p:nvSpPr>
+        <p:spPr>
+          <a:xfrm>
+            <a:off x="457200" y="657225"/>
+            <a:ext cx="11277600" cy="381000"/>
+          </a:xfrm>
+          <a:prstGeom prst="rect">
+            <a:avLst/>
+          </a:prstGeom>
+          <a:noFill/>
+          <a:ln w="0">
+            <a:noFill/>
+          </a:ln>
+        </p:spPr>
+        <p:txBody>
+          <a:bodyPr wrap="square" lIns="0" tIns="0" rIns="0" bIns="0" anchor="t">
+            <a:noAutofit/>
+          </a:bodyPr>
+          <a:lstStyle/>
+          <a:p>
+            <a:pPr algn="l">
+              <a:defRPr sz="2400" b="1">
+                <a:solidFill>
+                  <a:srgbClr val="333333"/>
+                </a:solidFill>
+                <a:latin typeface="Helvetica Neue"/>
+                <a:ea typeface="Helvetica Neue"/>
+                <a:cs typeface="Helvetica Neue"/>
+              </a:defRPr>
+            </a:pPr>
+            <a:r>
+              <a:rPr sz="2400" b="1">
+                <a:solidFill>
+                  <a:srgbClr val="333333"/>
+                </a:solidFill>
+                <a:latin typeface="Helvetica Neue"/>
+                <a:ea typeface="Helvetica Neue"/>
+                <a:cs typeface="Helvetica Neue"/>
+              </a:rPr>
+              <a:t>Цифровое самообслуживание</a:t>
+            </a:r>
+          </a:p>
+        </p:txBody>
+      </p:sp>
+      <p:sp>
+        <p:nvSpPr>
+          <p:cNvPr id="4" name="footer-rule">
+            <a:extLst>
+              <a:ext uri="{FF2B5EF4-FFF2-40B4-BE49-F238E27FC236}">
+                <a16:creationId xmlns:a16="http://schemas.microsoft.com/office/drawing/2014/main" id="{1877B535-BB3C-45FB-9440-4C6A72625F74}"/>
+              </a:ext>
+            </a:extLst>
+          </p:cNvPr>
+          <p:cNvSpPr>
+            <a:spLocks noGrp="1"/>
+          </p:cNvSpPr>
+          <p:nvPr/>
+        </p:nvSpPr>
+        <p:spPr>
+          <a:xfrm>
+            <a:off x="457200" y="6467475"/>
+            <a:ext cx="11277600" cy="0"/>
+          </a:xfrm>
+          <a:prstGeom prst="line">
+            <a:avLst/>
+          </a:prstGeom>
+          <a:noFill/>
+          <a:ln w="9525">
+            <a:solidFill>
+              <a:srgbClr val="EDEDED"/>
+            </a:solidFill>
+            <a:prstDash val="solid"/>
+          </a:ln>
+        </p:spPr>
+        <p:txBody>
+          <a:bodyPr/>
+          <a:lstStyle/>
+          <a:p>
+            <a:endParaRPr lang="en-JP"/>
+          </a:p>
+        </p:txBody>
+      </p:sp>
+      <p:sp>
+        <p:nvSpPr>
+          <p:cNvPr id="5" name="footer-reference">
+            <a:hlinkClick r:id="rId3" action="ppaction://hlinksldjump"/>
+            <a:extLst>
+              <a:ext uri="{FF2B5EF4-FFF2-40B4-BE49-F238E27FC236}">
+                <a16:creationId xmlns:a16="http://schemas.microsoft.com/office/drawing/2014/main" id="{1677C1CE-7A4E-4769-8303-F0EA781FC62D}"/>
+              </a:ext>
+            </a:extLst>
+          </p:cNvPr>
+          <p:cNvSpPr>
+            <a:spLocks noGrp="1"/>
+          </p:cNvSpPr>
+          <p:nvPr/>
+        </p:nvSpPr>
+        <p:spPr>
+          <a:xfrm>
+            <a:off x="457200" y="6591300"/>
+            <a:ext cx="10001250" cy="180975"/>
+          </a:xfrm>
+          <a:prstGeom prst="rect">
+            <a:avLst/>
+          </a:prstGeom>
+          <a:noFill/>
+          <a:ln w="0">
+            <a:noFill/>
+          </a:ln>
+        </p:spPr>
+        <p:txBody>
+          <a:bodyPr wrap="square" lIns="0" tIns="0" rIns="0" bIns="0" anchor="t">
+            <a:noAutofit/>
+          </a:bodyPr>
+          <a:lstStyle/>
+          <a:p>
+            <a:pPr algn="l">
+              <a:defRPr sz="900" b="0">
+                <a:solidFill>
+                  <a:srgbClr val="731982"/>
+                </a:solidFill>
+                <a:latin typeface="Helvetica Neue"/>
+                <a:ea typeface="Helvetica Neue"/>
+                <a:cs typeface="Helvetica Neue"/>
+              </a:defRPr>
+            </a:pPr>
+            <a:r>
+              <a:rPr sz="900" b="0" u="sng">
+                <a:solidFill>
+                  <a:srgbClr val="731982"/>
+                </a:solidFill>
+                <a:latin typeface="Helvetica Neue"/>
+                <a:ea typeface="Helvetica Neue"/>
+                <a:cs typeface="Helvetica Neue"/>
+              </a:rPr>
+              <a:t>Вернуться к шаблону · стр. 02</a:t>
+            </a:r>
+          </a:p>
+        </p:txBody>
+      </p:sp>
+      <p:sp>
+        <p:nvSpPr>
+          <p:cNvPr id="6" name="page">
+            <a:extLst>
+              <a:ext uri="{FF2B5EF4-FFF2-40B4-BE49-F238E27FC236}">
+                <a16:creationId xmlns:a16="http://schemas.microsoft.com/office/drawing/2014/main" id="{00D4170D-3CE9-455B-8517-7BD72A17E1EA}"/>
+              </a:ext>
+            </a:extLst>
+          </p:cNvPr>
+          <p:cNvSpPr>
+            <a:spLocks noGrp="1"/>
+          </p:cNvSpPr>
+          <p:nvPr/>
+        </p:nvSpPr>
+        <p:spPr>
+          <a:xfrm>
+            <a:off x="10725150" y="6591300"/>
+            <a:ext cx="1009650" cy="180975"/>
+          </a:xfrm>
+          <a:prstGeom prst="rect">
+            <a:avLst/>
+          </a:prstGeom>
+          <a:noFill/>
+          <a:ln w="0">
+            <a:noFill/>
+          </a:ln>
+        </p:spPr>
+        <p:txBody>
+          <a:bodyPr wrap="square" lIns="0" tIns="0" rIns="0" bIns="0" anchor="t">
+            <a:noAutofit/>
+          </a:bodyPr>
+          <a:lstStyle/>
+          <a:p>
+            <a:pPr algn="r">
+              <a:defRPr sz="900" b="0">
+                <a:solidFill>
+                  <a:srgbClr val="5F5F5F"/>
+                </a:solidFill>
+                <a:latin typeface="Helvetica Neue"/>
+                <a:ea typeface="Helvetica Neue"/>
+                <a:cs typeface="Helvetica Neue"/>
+              </a:defRPr>
+            </a:pPr>
+            <a:r>
+              <a:rPr sz="900" b="0">
+                <a:solidFill>
+                  <a:srgbClr val="5F5F5F"/>
+                </a:solidFill>
+                <a:latin typeface="Helvetica Neue"/>
+                <a:ea typeface="Helvetica Neue"/>
+                <a:cs typeface="Helvetica Neue"/>
+              </a:rPr>
+              <a:t>08 / 14</a:t>
+            </a:r>
+          </a:p>
+        </p:txBody>
+      </p:sp>
+      <p:sp>
+        <p:nvSpPr>
+          <p:cNvPr id="7" name="intro">
+            <a:extLst>
+              <a:ext uri="{FF2B5EF4-FFF2-40B4-BE49-F238E27FC236}">
+                <a16:creationId xmlns:a16="http://schemas.microsoft.com/office/drawing/2014/main" id="{F3692B4D-D3F1-4719-89E0-34936DBE1DD5}"/>
+              </a:ext>
+            </a:extLst>
+          </p:cNvPr>
+          <p:cNvSpPr>
+            <a:spLocks noGrp="1"/>
+          </p:cNvSpPr>
+          <p:nvPr/>
+        </p:nvSpPr>
+        <p:spPr>
+          <a:xfrm>
+            <a:off x="457200" y="1200150"/>
+            <a:ext cx="11277600" cy="495300"/>
+          </a:xfrm>
+          <a:prstGeom prst="rect">
+            <a:avLst/>
+          </a:prstGeom>
+          <a:noFill/>
+          <a:ln w="0">
+            <a:noFill/>
+          </a:ln>
+        </p:spPr>
+        <p:txBody>
+          <a:bodyPr wrap="square" lIns="0" tIns="0" rIns="0" bIns="0" anchor="t">
+            <a:noAutofit/>
+          </a:bodyPr>
+          <a:lstStyle/>
+          <a:p>
+            <a:pPr algn="l">
+              <a:defRPr sz="1275" b="0">
+                <a:solidFill>
+                  <a:srgbClr val="5F5F5F"/>
+                </a:solidFill>
+                <a:latin typeface="Helvetica Neue"/>
+                <a:ea typeface="Helvetica Neue"/>
+                <a:cs typeface="Helvetica Neue"/>
+              </a:defRPr>
+            </a:pPr>
+            <a:r>
+              <a:rPr sz="1275" b="0">
+                <a:solidFill>
+                  <a:srgbClr val="5F5F5F"/>
+                </a:solidFill>
+                <a:latin typeface="Helvetica Neue"/>
+                <a:ea typeface="Helvetica Neue"/>
+                <a:cs typeface="Helvetica Neue"/>
+              </a:rPr>
+              <a:t>Помогаем клиентам самостоятельно оплачивать связь, управлять тарифом и подключать сервисы в личном кабинете.</a:t>
+            </a:r>
+          </a:p>
+        </p:txBody>
+      </p:sp>
+      <p:sp>
+        <p:nvSpPr>
+          <p:cNvPr id="8" name="products-label">
+            <a:extLst>
+              <a:ext uri="{FF2B5EF4-FFF2-40B4-BE49-F238E27FC236}">
+                <a16:creationId xmlns:a16="http://schemas.microsoft.com/office/drawing/2014/main" id="{AE7E5CDB-5515-491E-81A2-2F638B6043C0}"/>
+              </a:ext>
+            </a:extLst>
+          </p:cNvPr>
+          <p:cNvSpPr>
+            <a:spLocks noGrp="1"/>
+          </p:cNvSpPr>
+          <p:nvPr/>
+        </p:nvSpPr>
+        <p:spPr>
+          <a:xfrm>
+            <a:off x="457200" y="1762125"/>
+            <a:ext cx="11277600" cy="285750"/>
+          </a:xfrm>
+          <a:prstGeom prst="rect">
+            <a:avLst/>
+          </a:prstGeom>
+          <a:noFill/>
+          <a:ln w="0">
+            <a:noFill/>
+          </a:ln>
+        </p:spPr>
+        <p:txBody>
+          <a:bodyPr wrap="square" lIns="0" tIns="0" rIns="0" bIns="0" anchor="t">
+            <a:noAutofit/>
+          </a:bodyPr>
+          <a:lstStyle/>
+          <a:p>
+            <a:pPr algn="l">
+              <a:defRPr sz="1500" b="1">
+                <a:solidFill>
+                  <a:srgbClr val="333333"/>
+                </a:solidFill>
+                <a:latin typeface="Helvetica Neue"/>
+                <a:ea typeface="Helvetica Neue"/>
+                <a:cs typeface="Helvetica Neue"/>
+              </a:defRPr>
+            </a:pPr>
+            <a:r>
+              <a:rPr sz="1500" b="1">
+                <a:solidFill>
+                  <a:srgbClr val="333333"/>
+                </a:solidFill>
+                <a:latin typeface="Helvetica Neue"/>
+                <a:ea typeface="Helvetica Neue"/>
+                <a:cs typeface="Helvetica Neue"/>
+              </a:rPr>
+              <a:t>Продукты внутри направления</a:t>
+            </a:r>
+          </a:p>
+        </p:txBody>
+      </p:sp>
+      <p:sp>
+        <p:nvSpPr>
+          <p:cNvPr id="9" name="product-surface-0">
+            <a:extLst>
+              <a:ext uri="{FF2B5EF4-FFF2-40B4-BE49-F238E27FC236}">
+                <a16:creationId xmlns:a16="http://schemas.microsoft.com/office/drawing/2014/main" id="{E91C77F1-FCBF-4DC1-B2B6-F87BC7B54597}"/>
+              </a:ext>
+            </a:extLst>
+          </p:cNvPr>
+          <p:cNvSpPr>
+            <a:spLocks noGrp="1"/>
+          </p:cNvSpPr>
+          <p:nvPr/>
+        </p:nvSpPr>
+        <p:spPr>
+          <a:xfrm>
+            <a:off x="457200" y="2143125"/>
+            <a:ext cx="1866900" cy="419100"/>
+          </a:xfrm>
+          <a:prstGeom prst="roundRect">
+            <a:avLst>
+              <a:gd name="adj" fmla="val 18182"/>
+            </a:avLst>
+          </a:prstGeom>
+          <a:solidFill>
+            <a:srgbClr val="F6F6F6"/>
+          </a:solidFill>
+          <a:ln w="0">
+            <a:noFill/>
+          </a:ln>
+        </p:spPr>
+        <p:txBody>
+          <a:bodyPr/>
+          <a:lstStyle/>
+          <a:p>
+            <a:endParaRPr lang="en-JP"/>
+          </a:p>
+        </p:txBody>
+      </p:sp>
+      <p:sp>
+        <p:nvSpPr>
+          <p:cNvPr id="10" name="product-0">
+            <a:extLst>
+              <a:ext uri="{FF2B5EF4-FFF2-40B4-BE49-F238E27FC236}">
+                <a16:creationId xmlns:a16="http://schemas.microsoft.com/office/drawing/2014/main" id="{C6B01A13-E514-4745-BBE8-AEB29449BD48}"/>
+              </a:ext>
+            </a:extLst>
+          </p:cNvPr>
+          <p:cNvSpPr>
+            <a:spLocks noGrp="1"/>
+          </p:cNvSpPr>
+          <p:nvPr/>
+        </p:nvSpPr>
+        <p:spPr>
+          <a:xfrm>
+            <a:off x="600075" y="2238375"/>
+            <a:ext cx="1581150" cy="238125"/>
+          </a:xfrm>
+          <a:prstGeom prst="rect">
+            <a:avLst/>
+          </a:prstGeom>
+          <a:noFill/>
+          <a:ln w="0">
+            <a:noFill/>
+          </a:ln>
+        </p:spPr>
+        <p:txBody>
+          <a:bodyPr wrap="square" lIns="0" tIns="0" rIns="0" bIns="0" anchor="t">
+            <a:noAutofit/>
+          </a:bodyPr>
+          <a:lstStyle/>
+          <a:p>
+            <a:pPr algn="l">
+              <a:defRPr sz="1200" b="0">
+                <a:solidFill>
+                  <a:srgbClr val="333333"/>
+                </a:solidFill>
+                <a:latin typeface="Helvetica Neue"/>
+                <a:ea typeface="Helvetica Neue"/>
+                <a:cs typeface="Helvetica Neue"/>
+              </a:defRPr>
+            </a:pPr>
+            <a:r>
+              <a:rPr sz="1200" b="0">
+                <a:solidFill>
+                  <a:srgbClr val="333333"/>
+                </a:solidFill>
+                <a:latin typeface="Helvetica Neue"/>
+                <a:ea typeface="Helvetica Neue"/>
+                <a:cs typeface="Helvetica Neue"/>
+              </a:rPr>
+              <a:t>Оплата и пополнение</a:t>
+            </a:r>
+          </a:p>
+        </p:txBody>
+      </p:sp>
+      <p:sp>
+        <p:nvSpPr>
+          <p:cNvPr id="11" name="product-surface-1">
+            <a:extLst>
+              <a:ext uri="{FF2B5EF4-FFF2-40B4-BE49-F238E27FC236}">
+                <a16:creationId xmlns:a16="http://schemas.microsoft.com/office/drawing/2014/main" id="{9A30CBB3-B774-486B-9672-FE137D886F58}"/>
+              </a:ext>
+            </a:extLst>
+          </p:cNvPr>
+          <p:cNvSpPr>
+            <a:spLocks noGrp="1"/>
+          </p:cNvSpPr>
+          <p:nvPr/>
+        </p:nvSpPr>
+        <p:spPr>
+          <a:xfrm>
+            <a:off x="2438400" y="2143125"/>
+            <a:ext cx="2657475" cy="419100"/>
+          </a:xfrm>
+          <a:prstGeom prst="roundRect">
+            <a:avLst>
+              <a:gd name="adj" fmla="val 18182"/>
+            </a:avLst>
+          </a:prstGeom>
+          <a:solidFill>
+            <a:srgbClr val="F6F6F6"/>
+          </a:solidFill>
+          <a:ln w="0">
+            <a:noFill/>
+          </a:ln>
+        </p:spPr>
+        <p:txBody>
+          <a:bodyPr/>
+          <a:lstStyle/>
+          <a:p>
+            <a:endParaRPr lang="en-JP"/>
+          </a:p>
+        </p:txBody>
+      </p:sp>
+      <p:sp>
+        <p:nvSpPr>
+          <p:cNvPr id="12" name="product-1">
+            <a:extLst>
+              <a:ext uri="{FF2B5EF4-FFF2-40B4-BE49-F238E27FC236}">
+                <a16:creationId xmlns:a16="http://schemas.microsoft.com/office/drawing/2014/main" id="{071849F6-62E5-4D2C-9C8C-8C5E8C5740FC}"/>
+              </a:ext>
+            </a:extLst>
+          </p:cNvPr>
+          <p:cNvSpPr>
+            <a:spLocks noGrp="1"/>
+          </p:cNvSpPr>
+          <p:nvPr/>
+        </p:nvSpPr>
+        <p:spPr>
+          <a:xfrm>
+            <a:off x="2581275" y="2238375"/>
+            <a:ext cx="2371725" cy="238125"/>
+          </a:xfrm>
+          <a:prstGeom prst="rect">
+            <a:avLst/>
+          </a:prstGeom>
+          <a:noFill/>
+          <a:ln w="0">
+            <a:noFill/>
+          </a:ln>
+        </p:spPr>
+        <p:txBody>
+          <a:bodyPr wrap="square" lIns="0" tIns="0" rIns="0" bIns="0" anchor="t">
+            <a:noAutofit/>
+          </a:bodyPr>
+          <a:lstStyle/>
+          <a:p>
+            <a:pPr algn="l">
+              <a:defRPr sz="1200" b="0">
+                <a:solidFill>
+                  <a:srgbClr val="333333"/>
+                </a:solidFill>
+                <a:latin typeface="Helvetica Neue"/>
+                <a:ea typeface="Helvetica Neue"/>
+                <a:cs typeface="Helvetica Neue"/>
+              </a:defRPr>
+            </a:pPr>
+            <a:r>
+              <a:rPr sz="1200" b="0">
+                <a:solidFill>
+                  <a:srgbClr val="333333"/>
+                </a:solidFill>
+                <a:latin typeface="Helvetica Neue"/>
+                <a:ea typeface="Helvetica Neue"/>
+                <a:cs typeface="Helvetica Neue"/>
+              </a:rPr>
+              <a:t>Управление тарифом и опциями</a:t>
+            </a:r>
+          </a:p>
+        </p:txBody>
+      </p:sp>
+      <p:sp>
+        <p:nvSpPr>
+          <p:cNvPr id="13" name="product-surface-2">
+            <a:extLst>
+              <a:ext uri="{FF2B5EF4-FFF2-40B4-BE49-F238E27FC236}">
+                <a16:creationId xmlns:a16="http://schemas.microsoft.com/office/drawing/2014/main" id="{DE0B5566-EC4A-4C83-8946-ABB2FE5D914A}"/>
+              </a:ext>
+            </a:extLst>
+          </p:cNvPr>
+          <p:cNvSpPr>
+            <a:spLocks noGrp="1"/>
+          </p:cNvSpPr>
+          <p:nvPr/>
+        </p:nvSpPr>
+        <p:spPr>
+          <a:xfrm>
+            <a:off x="5210175" y="2143125"/>
+            <a:ext cx="2647950" cy="419100"/>
+          </a:xfrm>
+          <a:prstGeom prst="roundRect">
+            <a:avLst>
+              <a:gd name="adj" fmla="val 18182"/>
+            </a:avLst>
+          </a:prstGeom>
+          <a:solidFill>
+            <a:srgbClr val="F6F6F6"/>
+          </a:solidFill>
+          <a:ln w="0">
+            <a:noFill/>
+          </a:ln>
+        </p:spPr>
+        <p:txBody>
+          <a:bodyPr/>
+          <a:lstStyle/>
+          <a:p>
+            <a:endParaRPr lang="en-JP"/>
+          </a:p>
+        </p:txBody>
+      </p:sp>
+      <p:sp>
+        <p:nvSpPr>
+          <p:cNvPr id="14" name="product-2">
+            <a:extLst>
+              <a:ext uri="{FF2B5EF4-FFF2-40B4-BE49-F238E27FC236}">
+                <a16:creationId xmlns:a16="http://schemas.microsoft.com/office/drawing/2014/main" id="{1A978EEE-9D3C-4981-9745-5EDD11946643}"/>
+              </a:ext>
+            </a:extLst>
+          </p:cNvPr>
+          <p:cNvSpPr>
+            <a:spLocks noGrp="1"/>
+          </p:cNvSpPr>
+          <p:nvPr/>
+        </p:nvSpPr>
+        <p:spPr>
+          <a:xfrm>
+            <a:off x="5353050" y="2238375"/>
+            <a:ext cx="2362200" cy="238125"/>
+          </a:xfrm>
+          <a:prstGeom prst="rect">
+            <a:avLst/>
+          </a:prstGeom>
+          <a:noFill/>
+          <a:ln w="0">
+            <a:noFill/>
+          </a:ln>
+        </p:spPr>
+        <p:txBody>
+          <a:bodyPr wrap="square" lIns="0" tIns="0" rIns="0" bIns="0" anchor="t">
+            <a:noAutofit/>
+          </a:bodyPr>
+          <a:lstStyle/>
+          <a:p>
+            <a:pPr algn="l">
+              <a:defRPr sz="1200" b="0">
+                <a:solidFill>
+                  <a:srgbClr val="333333"/>
+                </a:solidFill>
+                <a:latin typeface="Helvetica Neue"/>
+                <a:ea typeface="Helvetica Neue"/>
+                <a:cs typeface="Helvetica Neue"/>
+              </a:defRPr>
+            </a:pPr>
+            <a:r>
+              <a:rPr sz="1200" b="0">
+                <a:solidFill>
+                  <a:srgbClr val="333333"/>
+                </a:solidFill>
+                <a:latin typeface="Helvetica Neue"/>
+                <a:ea typeface="Helvetica Neue"/>
+                <a:cs typeface="Helvetica Neue"/>
+              </a:rPr>
+              <a:t>Подписки и семейные продукты</a:t>
+            </a:r>
+          </a:p>
+        </p:txBody>
+      </p:sp>
+      <p:sp>
+        <p:nvSpPr>
+          <p:cNvPr id="15" name="goals-label">
+            <a:extLst>
+              <a:ext uri="{FF2B5EF4-FFF2-40B4-BE49-F238E27FC236}">
+                <a16:creationId xmlns:a16="http://schemas.microsoft.com/office/drawing/2014/main" id="{E83C4AC7-82D7-4E6B-BD4D-2039DA477AB7}"/>
+              </a:ext>
+            </a:extLst>
+          </p:cNvPr>
+          <p:cNvSpPr>
+            <a:spLocks noGrp="1"/>
+          </p:cNvSpPr>
+          <p:nvPr/>
+        </p:nvSpPr>
+        <p:spPr>
+          <a:xfrm>
+            <a:off x="457200" y="2971800"/>
+            <a:ext cx="11277600" cy="285750"/>
+          </a:xfrm>
+          <a:prstGeom prst="rect">
+            <a:avLst/>
+          </a:prstGeom>
+          <a:noFill/>
+          <a:ln w="0">
+            <a:noFill/>
+          </a:ln>
+        </p:spPr>
+        <p:txBody>
+          <a:bodyPr wrap="square" lIns="0" tIns="0" rIns="0" bIns="0" anchor="t">
+            <a:noAutofit/>
+          </a:bodyPr>
+          <a:lstStyle/>
+          <a:p>
+            <a:pPr algn="l">
+              <a:defRPr sz="1500" b="1">
+                <a:solidFill>
+                  <a:srgbClr val="333333"/>
+                </a:solidFill>
+                <a:latin typeface="Helvetica Neue"/>
+                <a:ea typeface="Helvetica Neue"/>
+                <a:cs typeface="Helvetica Neue"/>
+              </a:defRPr>
+            </a:pPr>
+            <a:r>
+              <a:rPr sz="1500" b="1">
+                <a:solidFill>
+                  <a:srgbClr val="333333"/>
+                </a:solidFill>
+                <a:latin typeface="Helvetica Neue"/>
+                <a:ea typeface="Helvetica Neue"/>
+                <a:cs typeface="Helvetica Neue"/>
+              </a:rPr>
+              <a:t>Цели направления</a:t>
+            </a:r>
+          </a:p>
+        </p:txBody>
+      </p:sp>
+      <p:graphicFrame>
+        <p:nvGraphicFramePr>
+          <p:cNvPr id="33" name="Table 32"/>
+          <p:cNvGraphicFramePr/>
+          <p:nvPr>
+            <p:extLst>
+              <p:ext uri="{D42A27DB-BD31-4B8C-83A1-F6EECF244321}">
+                <p14:modId xmlns:p14="http://schemas.microsoft.com/office/powerpoint/2010/main" val="237564533"/>
+              </p:ext>
+            </p:extLst>
+          </p:nvPr>
+        </p:nvGraphicFramePr>
+        <p:xfrm>
+          <a:off x="457200" y="3371850"/>
+          <a:ext cx="10001250" cy="1819275"/>
+        </p:xfrm>
+        <a:graphic>
+          <a:graphicData uri="http://schemas.openxmlformats.org/drawingml/2006/table">
+            <a:tbl>
+              <a:tblPr/>
+              <a:tblGrid>
+                <a:gridCol w="4600575">
+                  <a:extLst>
+                    <a:ext uri="{9D8B030D-6E8A-4147-A177-3AD203B41FA5}">
+                      <a16:colId xmlns:a16="http://schemas.microsoft.com/office/drawing/2014/main" val="20000"/>
+                    </a:ext>
+                  </a:extLst>
+                </a:gridCol>
+                <a:gridCol w="5400675">
+                  <a:extLst>
+                    <a:ext uri="{9D8B030D-6E8A-4147-A177-3AD203B41FA5}">
+                      <a16:colId xmlns:a16="http://schemas.microsoft.com/office/drawing/2014/main" val="20001"/>
+                    </a:ext>
+                  </a:extLst>
+                </a:gridCol>
+              </a:tblGrid>
+              <a:tr h="447675">
+                <a:tc>
+                  <a:txBody>
+                    <a:bodyPr/>
+                    <a:lstStyle/>
+                    <a:p>
+                      <a:pPr algn="l">
+                        <a:lnSpc>
+                          <a:spcPts val="1365"/>
+                        </a:lnSpc>
+                        <a:spcBef>
+                          <a:spcPts val="0"/>
+                        </a:spcBef>
+                        <a:spcAft>
+                          <a:spcPts val="0"/>
+                        </a:spcAft>
+                      </a:pPr>
+                      <a:r>
+                        <a:rPr sz="1100" b="1">
+                          <a:solidFill>
+                            <a:srgbClr val="333333"/>
+                          </a:solidFill>
+                          <a:latin typeface="Helvetica Neue"/>
+                          <a:ea typeface="Helvetica Neue"/>
+                          <a:cs typeface="Helvetica Neue"/>
+                        </a:rPr>
+                        <a:t>Какой результат хотим получить</a:t>
+                      </a:r>
+                    </a:p>
+                  </a:txBody>
+                  <a:tcPr marL="114300" marR="114300" marT="123825" marB="123825">
+                    <a:lnL w="0">
+                      <a:noFill/>
+                    </a:lnL>
+                    <a:lnR w="0">
+                      <a:noFill/>
+                    </a:lnR>
+                    <a:lnT w="0">
+                      <a:noFill/>
+                    </a:lnT>
+                    <a:lnB w="9525">
+                      <a:solidFill>
+                        <a:srgbClr val="EDEDED"/>
+                      </a:solidFill>
+                    </a:lnB>
+                    <a:solidFill>
+                      <a:srgbClr val="F6F6F6"/>
+                    </a:solidFill>
+                  </a:tcPr>
+                </a:tc>
+                <a:tc>
+                  <a:txBody>
+                    <a:bodyPr/>
+                    <a:lstStyle/>
+                    <a:p>
+                      <a:pPr algn="l">
+                        <a:lnSpc>
+                          <a:spcPts val="1365"/>
+                        </a:lnSpc>
+                        <a:spcBef>
+                          <a:spcPts val="0"/>
+                        </a:spcBef>
+                        <a:spcAft>
+                          <a:spcPts val="0"/>
+                        </a:spcAft>
+                      </a:pPr>
+                      <a:r>
+                        <a:rPr sz="1100" b="1" dirty="0" err="1">
+                          <a:solidFill>
+                            <a:srgbClr val="333333"/>
+                          </a:solidFill>
+                          <a:latin typeface="Helvetica Neue"/>
+                          <a:ea typeface="Helvetica Neue"/>
+                          <a:cs typeface="Helvetica Neue"/>
+                        </a:rPr>
+                        <a:t>Как</a:t>
+                      </a:r>
+                      <a:r>
+                        <a:rPr sz="1100" b="1" dirty="0">
+                          <a:solidFill>
+                            <a:srgbClr val="333333"/>
+                          </a:solidFill>
+                          <a:latin typeface="Helvetica Neue"/>
+                          <a:ea typeface="Helvetica Neue"/>
+                          <a:cs typeface="Helvetica Neue"/>
+                        </a:rPr>
+                        <a:t> </a:t>
+                      </a:r>
+                      <a:r>
+                        <a:rPr sz="1100" b="1" dirty="0" err="1">
+                          <a:solidFill>
+                            <a:srgbClr val="333333"/>
+                          </a:solidFill>
+                          <a:latin typeface="Helvetica Neue"/>
+                          <a:ea typeface="Helvetica Neue"/>
+                          <a:cs typeface="Helvetica Neue"/>
+                        </a:rPr>
+                        <a:t>поймём</a:t>
+                      </a:r>
+                      <a:r>
+                        <a:rPr sz="1100" b="1" dirty="0">
+                          <a:solidFill>
+                            <a:srgbClr val="333333"/>
+                          </a:solidFill>
+                          <a:latin typeface="Helvetica Neue"/>
+                          <a:ea typeface="Helvetica Neue"/>
+                          <a:cs typeface="Helvetica Neue"/>
+                        </a:rPr>
+                        <a:t>, </a:t>
+                      </a:r>
+                      <a:r>
+                        <a:rPr sz="1100" b="1" dirty="0" err="1">
+                          <a:solidFill>
+                            <a:srgbClr val="333333"/>
+                          </a:solidFill>
+                          <a:latin typeface="Helvetica Neue"/>
+                          <a:ea typeface="Helvetica Neue"/>
+                          <a:cs typeface="Helvetica Neue"/>
+                        </a:rPr>
+                        <a:t>что</a:t>
+                      </a:r>
+                      <a:r>
+                        <a:rPr sz="1100" b="1" dirty="0">
+                          <a:solidFill>
+                            <a:srgbClr val="333333"/>
+                          </a:solidFill>
+                          <a:latin typeface="Helvetica Neue"/>
+                          <a:ea typeface="Helvetica Neue"/>
+                          <a:cs typeface="Helvetica Neue"/>
+                        </a:rPr>
+                        <a:t> </a:t>
+                      </a:r>
+                      <a:r>
+                        <a:rPr sz="1100" b="1" dirty="0" err="1">
+                          <a:solidFill>
+                            <a:srgbClr val="333333"/>
+                          </a:solidFill>
+                          <a:latin typeface="Helvetica Neue"/>
+                          <a:ea typeface="Helvetica Neue"/>
+                          <a:cs typeface="Helvetica Neue"/>
+                        </a:rPr>
+                        <a:t>достигли</a:t>
+                      </a:r>
+                      <a:r>
+                        <a:rPr sz="1100" b="1" dirty="0">
+                          <a:solidFill>
+                            <a:srgbClr val="333333"/>
+                          </a:solidFill>
+                          <a:latin typeface="Helvetica Neue"/>
+                          <a:ea typeface="Helvetica Neue"/>
+                          <a:cs typeface="Helvetica Neue"/>
+                        </a:rPr>
+                        <a:t> </a:t>
+                      </a:r>
+                      <a:r>
+                        <a:rPr sz="1100" b="1" dirty="0" err="1">
+                          <a:solidFill>
+                            <a:srgbClr val="333333"/>
+                          </a:solidFill>
+                          <a:latin typeface="Helvetica Neue"/>
+                          <a:ea typeface="Helvetica Neue"/>
+                          <a:cs typeface="Helvetica Neue"/>
+                        </a:rPr>
+                        <a:t>цели</a:t>
+                      </a:r>
+                      <a:endParaRPr sz="1100" b="1" dirty="0">
+                        <a:solidFill>
+                          <a:srgbClr val="333333"/>
+                        </a:solidFill>
+                        <a:latin typeface="Helvetica Neue"/>
+                        <a:ea typeface="Helvetica Neue"/>
+                        <a:cs typeface="Helvetica Neue"/>
+                      </a:endParaRPr>
+                    </a:p>
+                  </a:txBody>
+                  <a:tcPr marL="114300" marR="114300" marT="123825" marB="123825">
+                    <a:lnL w="0">
+                      <a:noFill/>
+                    </a:lnL>
+                    <a:lnR w="0">
+                      <a:noFill/>
+                    </a:lnR>
+                    <a:lnT w="0">
+                      <a:noFill/>
+                    </a:lnT>
+                    <a:lnB w="9525">
+                      <a:solidFill>
+                        <a:srgbClr val="EDEDED"/>
+                      </a:solidFill>
+                    </a:lnB>
+                    <a:solidFill>
+                      <a:srgbClr val="F6F6F6"/>
+                    </a:solidFill>
+                  </a:tcPr>
+                </a:tc>
+                <a:extLst>
+                  <a:ext uri="{0D108BD9-81ED-4DB2-BD59-A6C34878D82A}">
+                    <a16:rowId xmlns:a16="http://schemas.microsoft.com/office/drawing/2014/main" val="10000"/>
+                  </a:ext>
+                </a:extLst>
+              </a:tr>
+              <a:tr h="685800">
+                <a:tc>
+                  <a:txBody>
+                    <a:bodyPr/>
+                    <a:lstStyle/>
+                    <a:p>
+                      <a:pPr algn="l">
+                        <a:lnSpc>
+                          <a:spcPts val="1575"/>
+                        </a:lnSpc>
+                        <a:spcBef>
+                          <a:spcPts val="0"/>
+                        </a:spcBef>
+                        <a:spcAft>
+                          <a:spcPts val="0"/>
+                        </a:spcAft>
+                      </a:pPr>
+                      <a:r>
+                        <a:rPr sz="1125" b="0">
+                          <a:solidFill>
+                            <a:srgbClr val="333333"/>
+                          </a:solidFill>
+                          <a:latin typeface="Helvetica Neue"/>
+                          <a:ea typeface="Helvetica Neue"/>
+                          <a:cs typeface="Helvetica Neue"/>
+                        </a:rPr>
+                        <a:t>Клиенты успешно завершают оплату в ЛК.</a:t>
+                      </a:r>
+                    </a:p>
+                  </a:txBody>
+                  <a:tcPr marL="114300" marR="114300" marT="123825" marB="123825">
+                    <a:lnL w="0">
+                      <a:noFill/>
+                    </a:lnL>
+                    <a:lnR w="0">
+                      <a:noFill/>
+                    </a:lnR>
+                    <a:lnT w="9525" cap="flat" cmpd="sng" algn="ctr">
+                      <a:solidFill>
+                        <a:srgbClr val="EDEDED"/>
+                      </a:solidFill>
+                      <a:prstDash val="solid"/>
+                      <a:round/>
+                      <a:headEnd type="none" w="med" len="med"/>
+                      <a:tailEnd type="none" w="med" len="med"/>
+                    </a:lnT>
+                    <a:lnB w="9525">
+                      <a:solidFill>
+                        <a:srgbClr val="EDEDED"/>
+                      </a:solidFill>
+                    </a:lnB>
+                    <a:solidFill>
+                      <a:srgbClr val="FFFFFF"/>
+                    </a:solidFill>
+                  </a:tcPr>
+                </a:tc>
+                <a:tc>
+                  <a:txBody>
+                    <a:bodyPr/>
+                    <a:lstStyle/>
+                    <a:p>
+                      <a:pPr algn="l">
+                        <a:lnSpc>
+                          <a:spcPts val="1575"/>
+                        </a:lnSpc>
+                        <a:spcBef>
+                          <a:spcPts val="0"/>
+                        </a:spcBef>
+                        <a:spcAft>
+                          <a:spcPts val="0"/>
+                        </a:spcAft>
+                      </a:pPr>
+                      <a:r>
+                        <a:rPr sz="1125" b="0">
+                          <a:solidFill>
+                            <a:srgbClr val="5F5F5F"/>
+                          </a:solidFill>
+                          <a:latin typeface="Helvetica Neue"/>
+                          <a:ea typeface="Helvetica Neue"/>
+                          <a:cs typeface="Helvetica Neue"/>
+                        </a:rPr>
+                        <a:t>Доля успешных оплат — 73% попыток к 31.12.2026.</a:t>
+                      </a:r>
+                    </a:p>
+                  </a:txBody>
+                  <a:tcPr marL="114300" marR="114300" marT="123825" marB="123825">
+                    <a:lnL w="0">
+                      <a:noFill/>
+                    </a:lnL>
+                    <a:lnR w="0">
+                      <a:noFill/>
+                    </a:lnR>
+                    <a:lnT w="9525" cap="flat" cmpd="sng" algn="ctr">
+                      <a:solidFill>
+                        <a:srgbClr val="EDEDED"/>
+                      </a:solidFill>
+                      <a:prstDash val="solid"/>
+                      <a:round/>
+                      <a:headEnd type="none" w="med" len="med"/>
+                      <a:tailEnd type="none" w="med" len="med"/>
+                    </a:lnT>
+                    <a:lnB w="9525">
+                      <a:solidFill>
+                        <a:srgbClr val="EDEDED"/>
+                      </a:solidFill>
+                    </a:lnB>
+                    <a:solidFill>
+                      <a:srgbClr val="FFFFFF"/>
+                    </a:solidFill>
+                  </a:tcPr>
+                </a:tc>
+                <a:extLst>
+                  <a:ext uri="{0D108BD9-81ED-4DB2-BD59-A6C34878D82A}">
+                    <a16:rowId xmlns:a16="http://schemas.microsoft.com/office/drawing/2014/main" val="10001"/>
+                  </a:ext>
+                </a:extLst>
+              </a:tr>
+              <a:tr h="685800">
+                <a:tc>
+                  <a:txBody>
+                    <a:bodyPr/>
+                    <a:lstStyle/>
+                    <a:p>
+                      <a:pPr algn="l">
+                        <a:lnSpc>
+                          <a:spcPts val="1575"/>
+                        </a:lnSpc>
+                        <a:spcBef>
+                          <a:spcPts val="0"/>
+                        </a:spcBef>
+                        <a:spcAft>
+                          <a:spcPts val="0"/>
+                        </a:spcAft>
+                      </a:pPr>
+                      <a:r>
+                        <a:rPr sz="1125" b="0">
+                          <a:solidFill>
+                            <a:srgbClr val="333333"/>
+                          </a:solidFill>
+                          <a:latin typeface="Helvetica Neue"/>
+                          <a:ea typeface="Helvetica Neue"/>
+                          <a:cs typeface="Helvetica Neue"/>
+                        </a:rPr>
+                        <a:t>Клиентам понятен и удобен сценарий оплаты.</a:t>
+                      </a:r>
+                    </a:p>
+                  </a:txBody>
+                  <a:tcPr marL="114300" marR="114300" marT="123825" marB="123825">
+                    <a:lnL w="0">
+                      <a:noFill/>
+                    </a:lnL>
+                    <a:lnR w="0">
+                      <a:noFill/>
+                    </a:lnR>
+                    <a:lnT w="9525" cap="flat" cmpd="sng" algn="ctr">
+                      <a:solidFill>
+                        <a:srgbClr val="EDEDED"/>
+                      </a:solidFill>
+                      <a:prstDash val="solid"/>
+                      <a:round/>
+                      <a:headEnd type="none" w="med" len="med"/>
+                      <a:tailEnd type="none" w="med" len="med"/>
+                    </a:lnT>
+                    <a:lnB w="9525">
+                      <a:solidFill>
+                        <a:srgbClr val="EDEDED"/>
+                      </a:solidFill>
+                    </a:lnB>
+                    <a:solidFill>
+                      <a:srgbClr val="FFFFFF"/>
+                    </a:solidFill>
+                  </a:tcPr>
+                </a:tc>
+                <a:tc>
+                  <a:txBody>
+                    <a:bodyPr/>
+                    <a:lstStyle/>
+                    <a:p>
+                      <a:pPr algn="l">
+                        <a:lnSpc>
+                          <a:spcPts val="1575"/>
+                        </a:lnSpc>
+                        <a:spcBef>
+                          <a:spcPts val="0"/>
+                        </a:spcBef>
+                        <a:spcAft>
+                          <a:spcPts val="0"/>
+                        </a:spcAft>
+                      </a:pPr>
+                      <a:r>
+                        <a:rPr sz="1125" b="0" dirty="0">
+                          <a:solidFill>
+                            <a:srgbClr val="5F5F5F"/>
+                          </a:solidFill>
+                          <a:latin typeface="Helvetica Neue"/>
+                          <a:ea typeface="Helvetica Neue"/>
+                          <a:cs typeface="Helvetica Neue"/>
+                        </a:rPr>
+                        <a:t>CSI </a:t>
+                      </a:r>
+                      <a:r>
+                        <a:rPr sz="1125" b="0" dirty="0" err="1">
+                          <a:solidFill>
+                            <a:srgbClr val="5F5F5F"/>
+                          </a:solidFill>
+                          <a:latin typeface="Helvetica Neue"/>
+                          <a:ea typeface="Helvetica Neue"/>
+                          <a:cs typeface="Helvetica Neue"/>
+                        </a:rPr>
+                        <a:t>оплаты</a:t>
+                      </a:r>
+                      <a:r>
+                        <a:rPr sz="1125" b="0" dirty="0">
+                          <a:solidFill>
+                            <a:srgbClr val="5F5F5F"/>
+                          </a:solidFill>
+                          <a:latin typeface="Helvetica Neue"/>
+                          <a:ea typeface="Helvetica Neue"/>
+                          <a:cs typeface="Helvetica Neue"/>
+                        </a:rPr>
+                        <a:t> — 78 </a:t>
+                      </a:r>
+                      <a:r>
+                        <a:rPr sz="1125" b="0" dirty="0" err="1">
+                          <a:solidFill>
+                            <a:srgbClr val="5F5F5F"/>
+                          </a:solidFill>
+                          <a:latin typeface="Helvetica Neue"/>
+                          <a:ea typeface="Helvetica Neue"/>
+                          <a:cs typeface="Helvetica Neue"/>
+                        </a:rPr>
+                        <a:t>баллов</a:t>
+                      </a:r>
+                      <a:r>
+                        <a:rPr sz="1125" b="0" dirty="0">
+                          <a:solidFill>
+                            <a:srgbClr val="5F5F5F"/>
+                          </a:solidFill>
+                          <a:latin typeface="Helvetica Neue"/>
+                          <a:ea typeface="Helvetica Neue"/>
+                          <a:cs typeface="Helvetica Neue"/>
+                        </a:rPr>
+                        <a:t> </a:t>
+                      </a:r>
+                      <a:r>
+                        <a:rPr sz="1125" b="0" dirty="0" err="1">
+                          <a:solidFill>
+                            <a:srgbClr val="5F5F5F"/>
+                          </a:solidFill>
+                          <a:latin typeface="Helvetica Neue"/>
+                          <a:ea typeface="Helvetica Neue"/>
+                          <a:cs typeface="Helvetica Neue"/>
+                        </a:rPr>
+                        <a:t>к</a:t>
+                      </a:r>
+                      <a:r>
+                        <a:rPr sz="1125" b="0" dirty="0">
+                          <a:solidFill>
+                            <a:srgbClr val="5F5F5F"/>
+                          </a:solidFill>
+                          <a:latin typeface="Helvetica Neue"/>
+                          <a:ea typeface="Helvetica Neue"/>
+                          <a:cs typeface="Helvetica Neue"/>
+                        </a:rPr>
+                        <a:t> 31.12.2026.</a:t>
+                      </a:r>
+                    </a:p>
+                  </a:txBody>
+                  <a:tcPr marL="114300" marR="114300" marT="123825" marB="123825">
+                    <a:lnL w="0">
+                      <a:noFill/>
+                    </a:lnL>
+                    <a:lnR w="0">
+                      <a:noFill/>
+                    </a:lnR>
+                    <a:lnT w="9525" cap="flat" cmpd="sng" algn="ctr">
+                      <a:solidFill>
+                        <a:srgbClr val="EDEDED"/>
+                      </a:solidFill>
+                      <a:prstDash val="solid"/>
+                      <a:round/>
+                      <a:headEnd type="none" w="med" len="med"/>
+                      <a:tailEnd type="none" w="med" len="med"/>
+                    </a:lnT>
+                    <a:lnB w="9525">
+                      <a:solidFill>
+                        <a:srgbClr val="EDEDED"/>
+                      </a:solidFill>
+                    </a:lnB>
+                    <a:solidFill>
+                      <a:srgbClr val="FFFFFF"/>
+                    </a:solidFill>
+                  </a:tcPr>
+                </a:tc>
+                <a:extLst>
+                  <a:ext uri="{0D108BD9-81ED-4DB2-BD59-A6C34878D82A}">
+                    <a16:rowId xmlns:a16="http://schemas.microsoft.com/office/drawing/2014/main" val="10002"/>
+                  </a:ext>
+                </a:extLst>
+              </a:tr>
+            </a:tbl>
+          </a:graphicData>
+        </a:graphic>
+      </p:graphicFrame>
+      <p:sp>
+        <p:nvSpPr>
+          <p:cNvPr id="17" name="instruction">
+            <a:extLst>
+              <a:ext uri="{FF2B5EF4-FFF2-40B4-BE49-F238E27FC236}">
+                <a16:creationId xmlns:a16="http://schemas.microsoft.com/office/drawing/2014/main" id="{066B7228-B225-4154-B3F6-79BBD02070B5}"/>
+              </a:ext>
+            </a:extLst>
+          </p:cNvPr>
+          <p:cNvSpPr>
+            <a:spLocks noGrp="1"/>
+          </p:cNvSpPr>
+          <p:nvPr/>
+        </p:nvSpPr>
+        <p:spPr>
+          <a:xfrm>
+            <a:off x="457200" y="5381625"/>
+            <a:ext cx="11277600" cy="400050"/>
+          </a:xfrm>
+          <a:prstGeom prst="rect">
+            <a:avLst/>
+          </a:prstGeom>
+          <a:noFill/>
+          <a:ln w="0">
+            <a:noFill/>
+          </a:ln>
+        </p:spPr>
+        <p:txBody>
+          <a:bodyPr wrap="square" lIns="0" tIns="0" rIns="0" bIns="0" anchor="t">
+            <a:noAutofit/>
+          </a:bodyPr>
+          <a:lstStyle/>
+          <a:p>
+            <a:pPr algn="l">
+              <a:defRPr sz="1050" b="0">
+                <a:solidFill>
+                  <a:srgbClr val="5F5F5F"/>
+                </a:solidFill>
+                <a:latin typeface="Helvetica Neue"/>
+                <a:ea typeface="Helvetica Neue"/>
+                <a:cs typeface="Helvetica Neue"/>
+              </a:defRPr>
+            </a:pPr>
+            <a:r>
+              <a:rPr sz="1050" b="0">
+                <a:solidFill>
+                  <a:srgbClr val="5F5F5F"/>
+                </a:solidFill>
+                <a:latin typeface="Helvetica Neue"/>
+                <a:ea typeface="Helvetica Neue"/>
+                <a:cs typeface="Helvetica Neue"/>
+              </a:rPr>
+              <a:t>Это один из вариантов подачи. Команда может рассказать о направлении иначе, сохранив продукты и цели.</a:t>
+            </a:r>
+          </a:p>
+        </p:txBody>
+      </p:sp>
+    </p:spTree>
+    <p:extLst>
+      <p:ext uri="{BB962C8B-B14F-4D97-AF65-F5344CB8AC3E}">
+        <p14:creationId xmlns:p14="http://schemas.microsoft.com/office/powerpoint/2010/main" val="395856596"/>
+      </p:ext>
+    </p:extLst>
+  </p:cSld>
+  <p:clrMapOvr>
+    <a:masterClrMapping/>
+  </p:clrMapOvr>
+</p:sld>
+</file>
+
+<file path=ppt/slides/slide11.xml><?xml version="1.0" encoding="utf-8"?>
+<p:sld xmlns:a="http://schemas.openxmlformats.org/drawingml/2006/main" xmlns:r="http://schemas.openxmlformats.org/officeDocument/2006/relationships" xmlns:p="http://schemas.openxmlformats.org/presentationml/2006/main">
+  <p:cSld>
+    <p:bg>
+      <p:bgPr>
+        <a:solidFill>
+          <a:srgbClr val="FFFFFF"/>
+        </a:solidFill>
+        <a:effectLst/>
+      </p:bgPr>
+    </p:bg>
+    <p:spTree>
+      <p:nvGrpSpPr>
+        <p:cNvPr id="1" name=""/>
+        <p:cNvGrpSpPr/>
+        <p:nvPr/>
+      </p:nvGrpSpPr>
+      <p:grpSpPr>
+        <a:xfrm>
+          <a:off x="0" y="0"/>
+          <a:ext cx="0" cy="0"/>
+          <a:chOff x="0" y="0"/>
+          <a:chExt cx="0" cy="0"/>
+        </a:xfrm>
+      </p:grpSpPr>
+      <p:sp>
+        <p:nvSpPr>
           <p:cNvPr id="10" name="section">
             <a:extLst>
               <a:ext uri="{FF2B5EF4-FFF2-40B4-BE49-F238E27FC236}">
@@ -6710,7 +8130,7 @@
 </p:sld>
 </file>
 
-<file path=ppt/slides/slide11.xml><?xml version="1.0" encoding="utf-8"?>
+<file path=ppt/slides/slide12.xml><?xml version="1.0" encoding="utf-8"?>
 <p:sld xmlns:a="http://schemas.openxmlformats.org/drawingml/2006/main" xmlns:r="http://schemas.openxmlformats.org/officeDocument/2006/relationships" xmlns:p="http://schemas.openxmlformats.org/presentationml/2006/main">
   <p:cSld>
     <p:bg>
@@ -8923,7 +10343,7 @@
 </p:sld>
 </file>
 
-<file path=ppt/slides/slide12.xml><?xml version="1.0" encoding="utf-8"?>
+<file path=ppt/slides/slide13.xml><?xml version="1.0" encoding="utf-8"?>
 <p:sld xmlns:a="http://schemas.openxmlformats.org/drawingml/2006/main" xmlns:r="http://schemas.openxmlformats.org/officeDocument/2006/relationships" xmlns:p="http://schemas.openxmlformats.org/presentationml/2006/main">
   <p:cSld>
     <p:bg>
@@ -10956,7 +12376,7 @@
 </p:sld>
 </file>
 
-<file path=ppt/slides/slide13.xml><?xml version="1.0" encoding="utf-8"?>
+<file path=ppt/slides/slide14.xml><?xml version="1.0" encoding="utf-8"?>
 <p:sld xmlns:a="http://schemas.openxmlformats.org/drawingml/2006/main" xmlns:r="http://schemas.openxmlformats.org/officeDocument/2006/relationships" xmlns:p="http://schemas.openxmlformats.org/presentationml/2006/main">
   <p:cSld>
     <p:bg>
@@ -12968,7 +14388,7 @@
 </p:sld>
 </file>
 
-<file path=ppt/slides/slide14.xml><?xml version="1.0" encoding="utf-8"?>
+<file path=ppt/slides/slide15.xml><?xml version="1.0" encoding="utf-8"?>
 <p:sld xmlns:a="http://schemas.openxmlformats.org/drawingml/2006/main" xmlns:r="http://schemas.openxmlformats.org/officeDocument/2006/relationships" xmlns:p="http://schemas.openxmlformats.org/presentationml/2006/main">
   <p:cSld>
     <p:bg>
@@ -15344,7 +16764,7 @@
                 <a:ea typeface="Helvetica Neue"/>
                 <a:cs typeface="Helvetica Neue"/>
               </a:rPr>
-              <a:t>Портфель «Мега5G»: витрина в приложении и лендинг на сайте.</a:t>
+              <a:t>Портфель «Мега5G»: витрина в приложении и лендинг на сайте. Дом групповых продуктов: семейная платформа МегаСемья 2.0, персональные роли для номеров близких.</a:t>
             </a:r>
           </a:p>
         </p:txBody>
@@ -15739,7 +17159,7 @@
                 <a:ea typeface="Helvetica Neue"/>
                 <a:cs typeface="Helvetica Neue"/>
               </a:rPr>
-              <a:t>Растить сценарии активации в продукты МегаИнтернета, и улучшать клиентский опыт.</a:t>
+              <a:t>Мега5G. Растить сценарии активации в продукты МегаИнтернета, и улучшать клиентский опыт. Дом групповых продуктов. Создание и внедрение семейных механик на витринах для улучшение клиентского опыта и развитие разметки сегментов.</a:t>
             </a:r>
           </a:p>
         </p:txBody>
@@ -15891,7 +17311,125 @@
                 <a:ea typeface="Helvetica Neue"/>
                 <a:cs typeface="Helvetica Neue"/>
               </a:rPr>
-              <a:t>Подключения — 10. Конверсия — план не задан. GM — 4 млн.</a:t>
+              <a:t>Мега5G. Подключения — 10. Конверсия — план не задан. GM — 4 млн. Дом групповых продуктов. Подключения — 1,6 млн на 2026 год.</a:t>
+            </a:r>
+          </a:p>
+        </p:txBody>
+      </p:sp>
+      <p:sp>
+        <p:nvSpPr>
+          <p:cNvPr id="23" name="product-surface-1">
+            <a:extLst>
+              <a:ext uri="{FF2B5EF4-FFF2-40B4-BE49-F238E27FC236}">
+                <a16:creationId xmlns:a16="http://schemas.microsoft.com/office/drawing/2014/main" id="{9EA0A1CC-7533-4448-811E-D69F188F31B7}"/>
+              </a:ext>
+            </a:extLst>
+          </p:cNvPr>
+          <p:cNvSpPr>
+            <a:spLocks noGrp="1"/>
+          </p:cNvSpPr>
+          <p:nvPr/>
+        </p:nvSpPr>
+        <p:spPr>
+          <a:xfrm>
+            <a:off x="2735580" y="2447925"/>
+            <a:ext cx="3200400" cy="419100"/>
+          </a:xfrm>
+          <a:prstGeom prst="roundRect">
+            <a:avLst>
+              <a:gd name="adj" fmla="val 18182"/>
+            </a:avLst>
+          </a:prstGeom>
+          <a:solidFill>
+            <a:srgbClr val="F6F6F6"/>
+          </a:solidFill>
+          <a:ln w="0">
+            <a:noFill/>
+          </a:ln>
+        </p:spPr>
+        <p:txBody>
+          <a:bodyPr/>
+          <a:lstStyle/>
+          <a:p>
+            <a:endParaRPr lang="en-JP"/>
+          </a:p>
+        </p:txBody>
+      </p:sp>
+      <p:sp>
+        <p:nvSpPr>
+          <p:cNvPr id="24" name="product-field-1">
+            <a:extLst>
+              <a:ext uri="{FF2B5EF4-FFF2-40B4-BE49-F238E27FC236}">
+                <a16:creationId xmlns:a16="http://schemas.microsoft.com/office/drawing/2014/main" id="{218BF7B7-7052-4583-B32D-A93D2C8D1151}"/>
+              </a:ext>
+            </a:extLst>
+          </p:cNvPr>
+          <p:cNvSpPr>
+            <a:spLocks noGrp="1"/>
+          </p:cNvSpPr>
+          <p:nvPr/>
+        </p:nvSpPr>
+        <p:spPr>
+          <a:xfrm>
+            <a:off x="2878455" y="2543175"/>
+            <a:ext cx="2914650" cy="238125"/>
+          </a:xfrm>
+          <a:prstGeom prst="rect">
+            <a:avLst/>
+          </a:prstGeom>
+          <a:noFill/>
+          <a:ln w="0">
+            <a:noFill/>
+          </a:ln>
+        </p:spPr>
+        <p:txBody>
+          <a:bodyPr wrap="square" lIns="0" tIns="0" rIns="0" bIns="0" anchor="t">
+            <a:noAutofit/>
+          </a:bodyPr>
+          <a:lstStyle/>
+          <a:p>
+            <a:pPr algn="l">
+              <a:defRPr sz="1200" b="0">
+                <a:solidFill>
+                  <a:srgbClr val="666666"/>
+                </a:solidFill>
+                <a:latin typeface="Helvetica Neue"/>
+                <a:ea typeface="Helvetica Neue"/>
+                <a:cs typeface="Helvetica Neue"/>
+              </a:defRPr>
+            </a:pPr>
+            <a:r>
+              <a:rPr sz="1200" b="0" dirty="0">
+                <a:solidFill>
+                  <a:srgbClr val="666666"/>
+                </a:solidFill>
+                <a:latin typeface="Helvetica Neue"/>
+                <a:ea typeface="Helvetica Neue"/>
+                <a:cs typeface="Helvetica Neue"/>
+              </a:rPr>
+              <a:t>Дом групповых продуктов</a:t>
+            </a:r>
+            <a:r>
+              <a:rPr sz="1200" b="0" dirty="0" err="1">
+                <a:solidFill>
+                  <a:srgbClr val="666666"/>
+                </a:solidFill>
+                <a:latin typeface="Helvetica Neue"/>
+                <a:ea typeface="Helvetica Neue"/>
+                <a:cs typeface="Helvetica Neue"/>
+              </a:rPr>
+              <a:t/>
+            </a:r>
+            <a:r>
+              <a:rPr sz="1200" b="0" dirty="0">
+                <a:solidFill>
+                  <a:srgbClr val="666666"/>
+                </a:solidFill>
+                <a:latin typeface="Helvetica Neue"/>
+                <a:ea typeface="Helvetica Neue"/>
+                <a:cs typeface="Helvetica Neue"/>
+              </a:rPr>
+              <a:t/>
             </a:r>
           </a:p>
         </p:txBody>
@@ -16329,7 +17867,7 @@
         </p:nvGraphicFramePr>
         <p:xfrm>
           <a:off x="457200" y="1752600"/>
-          <a:ext cx="11277600" cy="4029075"/>
+          <a:ext cx="11277600" cy="3880000"/>
         </p:xfrm>
         <a:graphic>
           <a:graphicData uri="http://schemas.openxmlformats.org/drawingml/2006/table">
@@ -16372,7 +17910,7 @@
                   </a:extLst>
                 </a:gridCol>
               </a:tblGrid>
-              <a:tr h="447675">
+              <a:tr h="380000">
                 <a:tc>
                   <a:txBody>
                     <a:bodyPr/>
@@ -16687,7 +18225,7 @@
                   </a:ext>
                 </a:extLst>
               </a:tr>
-              <a:tr h="895350">
+              <a:tr h="700000">
                 <a:tc>
                   <a:txBody>
                     <a:bodyPr/>
@@ -16993,7 +18531,7 @@
                   </a:ext>
                 </a:extLst>
               </a:tr>
-              <a:tr h="895350">
+              <a:tr h="700000">
                 <a:tc>
                   <a:txBody>
                     <a:bodyPr/>
@@ -17299,7 +18837,7 @@
                   </a:ext>
                 </a:extLst>
               </a:tr>
-              <a:tr h="895350">
+              <a:tr h="700000">
                 <a:tc>
                   <a:txBody>
                     <a:bodyPr/>
@@ -17515,6 +19053,618 @@
                           <a:cs typeface="Helvetica Neue"/>
                         </a:rPr>
                         <a:t/>
+                      </a:r>
+                    </a:p>
+                  </a:txBody>
+                  <a:tcPr marL="114300" marR="114300" marT="123825" marB="123825">
+                    <a:lnL w="0">
+                      <a:noFill/>
+                    </a:lnL>
+                    <a:lnR w="0">
+                      <a:noFill/>
+                    </a:lnR>
+                    <a:lnT w="9525" cap="flat" cmpd="sng" algn="ctr">
+                      <a:solidFill>
+                        <a:srgbClr val="EDEDED"/>
+                      </a:solidFill>
+                      <a:prstDash val="solid"/>
+                      <a:round/>
+                      <a:headEnd type="none" w="med" len="med"/>
+                      <a:tailEnd type="none" w="med" len="med"/>
+                    </a:lnT>
+                    <a:lnB w="9525">
+                      <a:solidFill>
+                        <a:srgbClr val="EDEDED"/>
+                      </a:solidFill>
+                    </a:lnB>
+                    <a:solidFill>
+                      <a:srgbClr val="FFFFFF"/>
+                    </a:solidFill>
+                  </a:tcPr>
+                </a:tc>
+                <a:tc>
+                  <a:txBody>
+                    <a:bodyPr/>
+                    <a:lstStyle/>
+                    <a:p>
+                      <a:pPr algn="l">
+                        <a:lnSpc>
+                          <a:spcPts val="1575"/>
+                        </a:lnSpc>
+                        <a:spcBef>
+                          <a:spcPts val="0"/>
+                        </a:spcBef>
+                        <a:spcAft>
+                          <a:spcPts val="0"/>
+                        </a:spcAft>
+                      </a:pPr>
+                      <a:r>
+                        <a:rPr sz="1125" b="0">
+                          <a:solidFill>
+                            <a:srgbClr val="666666"/>
+                          </a:solidFill>
+                          <a:latin typeface="Helvetica Neue"/>
+                          <a:ea typeface="Helvetica Neue"/>
+                          <a:cs typeface="Helvetica Neue"/>
+                        </a:rPr>
+                        <a:t/>
+                      </a:r>
+                    </a:p>
+                  </a:txBody>
+                  <a:tcPr marL="114300" marR="114300" marT="123825" marB="123825">
+                    <a:lnL w="0">
+                      <a:noFill/>
+                    </a:lnL>
+                    <a:lnR w="0">
+                      <a:noFill/>
+                    </a:lnR>
+                    <a:lnT w="9525" cap="flat" cmpd="sng" algn="ctr">
+                      <a:solidFill>
+                        <a:srgbClr val="EDEDED"/>
+                      </a:solidFill>
+                      <a:prstDash val="solid"/>
+                      <a:round/>
+                      <a:headEnd type="none" w="med" len="med"/>
+                      <a:tailEnd type="none" w="med" len="med"/>
+                    </a:lnT>
+                    <a:lnB w="9525">
+                      <a:solidFill>
+                        <a:srgbClr val="EDEDED"/>
+                      </a:solidFill>
+                    </a:lnB>
+                    <a:solidFill>
+                      <a:srgbClr val="FFFFFF"/>
+                    </a:solidFill>
+                  </a:tcPr>
+                </a:tc>
+                <a:extLst>
+                  <a:ext uri="{0D108BD9-81ED-4DB2-BD59-A6C34878D82A}">
+                    <a16:rowId xmlns:a16="http://schemas.microsoft.com/office/drawing/2014/main" val="10003"/>
+                  </a:ext>
+                </a:extLst>
+              </a:tr>
+              <a:tr h="700000">
+                <a:tc>
+                  <a:txBody>
+                    <a:bodyPr/>
+                    <a:lstStyle/>
+                    <a:p>
+                      <a:pPr algn="l">
+                        <a:lnSpc>
+                          <a:spcPts val="1260"/>
+                        </a:lnSpc>
+                        <a:spcBef>
+                          <a:spcPts val="0"/>
+                        </a:spcBef>
+                        <a:spcAft>
+                          <a:spcPts val="375"/>
+                        </a:spcAft>
+                      </a:pPr>
+                      <a:r>
+                        <a:rPr sz="900" b="1">
+                          <a:solidFill>
+                            <a:srgbClr val="01873F"/>
+                          </a:solidFill>
+                          <a:latin typeface="Helvetica Neue"/>
+                          <a:ea typeface="Helvetica Neue"/>
+                          <a:cs typeface="Helvetica Neue"/>
+                        </a:rPr>
+                        <a:t>Продукт</a:t>
+                      </a:r>
+                    </a:p>
+                    <a:p>
+                      <a:pPr algn="l">
+                        <a:lnSpc>
+                          <a:spcPts val="1575"/>
+                        </a:lnSpc>
+                        <a:spcBef>
+                          <a:spcPts val="0"/>
+                        </a:spcBef>
+                        <a:spcAft>
+                          <a:spcPts val="0"/>
+                        </a:spcAft>
+                      </a:pPr>
+                      <a:r>
+                        <a:rPr sz="1125" b="0">
+                          <a:solidFill>
+                            <a:srgbClr val="666666"/>
+                          </a:solidFill>
+                          <a:latin typeface="Helvetica Neue"/>
+                          <a:ea typeface="Helvetica Neue"/>
+                          <a:cs typeface="Helvetica Neue"/>
+                        </a:rPr>
+                        <a:t>Дом групповых продуктов · Конверсия в назначение роли</a:t>
+                      </a:r>
+                    </a:p>
+                  </a:txBody>
+                  <a:tcPr marL="114300" marR="114300" marT="123825" marB="123825">
+                    <a:lnL w="0">
+                      <a:noFill/>
+                    </a:lnL>
+                    <a:lnR w="0">
+                      <a:noFill/>
+                    </a:lnR>
+                    <a:lnT w="9525" cap="flat" cmpd="sng" algn="ctr">
+                      <a:solidFill>
+                        <a:srgbClr val="EDEDED"/>
+                      </a:solidFill>
+                      <a:prstDash val="solid"/>
+                      <a:round/>
+                      <a:headEnd type="none" w="med" len="med"/>
+                      <a:tailEnd type="none" w="med" len="med"/>
+                    </a:lnT>
+                    <a:lnB w="9525">
+                      <a:solidFill>
+                        <a:srgbClr val="EDEDED"/>
+                      </a:solidFill>
+                    </a:lnB>
+                    <a:solidFill>
+                      <a:srgbClr val="FFFFFF"/>
+                    </a:solidFill>
+                  </a:tcPr>
+                </a:tc>
+                <a:tc>
+                  <a:txBody>
+                    <a:bodyPr/>
+                    <a:lstStyle/>
+                    <a:p>
+                      <a:pPr algn="l">
+                        <a:lnSpc>
+                          <a:spcPts val="1575"/>
+                        </a:lnSpc>
+                        <a:spcBef>
+                          <a:spcPts val="0"/>
+                        </a:spcBef>
+                        <a:spcAft>
+                          <a:spcPts val="0"/>
+                        </a:spcAft>
+                      </a:pPr>
+                      <a:r>
+                        <a:rPr sz="1125" b="0">
+                          <a:solidFill>
+                            <a:srgbClr val="666666"/>
+                          </a:solidFill>
+                          <a:latin typeface="Helvetica Neue"/>
+                          <a:ea typeface="Helvetica Neue"/>
+                          <a:cs typeface="Helvetica Neue"/>
+                        </a:rPr>
+                        <a:t>25%</a:t>
+                      </a:r>
+                    </a:p>
+                  </a:txBody>
+                  <a:tcPr marL="114300" marR="114300" marT="123825" marB="123825">
+                    <a:lnL w="0">
+                      <a:noFill/>
+                    </a:lnL>
+                    <a:lnR w="0">
+                      <a:noFill/>
+                    </a:lnR>
+                    <a:lnT w="9525" cap="flat" cmpd="sng" algn="ctr">
+                      <a:solidFill>
+                        <a:srgbClr val="EDEDED"/>
+                      </a:solidFill>
+                      <a:prstDash val="solid"/>
+                      <a:round/>
+                      <a:headEnd type="none" w="med" len="med"/>
+                      <a:tailEnd type="none" w="med" len="med"/>
+                    </a:lnT>
+                    <a:lnB w="9525">
+                      <a:solidFill>
+                        <a:srgbClr val="EDEDED"/>
+                      </a:solidFill>
+                    </a:lnB>
+                    <a:solidFill>
+                      <a:srgbClr val="FFFFFF"/>
+                    </a:solidFill>
+                  </a:tcPr>
+                </a:tc>
+                <a:tc>
+                  <a:txBody>
+                    <a:bodyPr/>
+                    <a:lstStyle/>
+                    <a:p>
+                      <a:pPr algn="l">
+                        <a:lnSpc>
+                          <a:spcPts val="1575"/>
+                        </a:lnSpc>
+                        <a:spcBef>
+                          <a:spcPts val="0"/>
+                        </a:spcBef>
+                        <a:spcAft>
+                          <a:spcPts val="0"/>
+                        </a:spcAft>
+                      </a:pPr>
+                      <a:r>
+                        <a:rPr sz="1125" b="0">
+                          <a:solidFill>
+                            <a:srgbClr val="666666"/>
+                          </a:solidFill>
+                          <a:latin typeface="Helvetica Neue"/>
+                          <a:ea typeface="Helvetica Neue"/>
+                          <a:cs typeface="Helvetica Neue"/>
+                        </a:rPr>
+                        <a:t>31%</a:t>
+                      </a:r>
+                    </a:p>
+                  </a:txBody>
+                  <a:tcPr marL="114300" marR="114300" marT="123825" marB="123825">
+                    <a:lnL w="0">
+                      <a:noFill/>
+                    </a:lnL>
+                    <a:lnR w="0">
+                      <a:noFill/>
+                    </a:lnR>
+                    <a:lnT w="9525" cap="flat" cmpd="sng" algn="ctr">
+                      <a:solidFill>
+                        <a:srgbClr val="EDEDED"/>
+                      </a:solidFill>
+                      <a:prstDash val="solid"/>
+                      <a:round/>
+                      <a:headEnd type="none" w="med" len="med"/>
+                      <a:tailEnd type="none" w="med" len="med"/>
+                    </a:lnT>
+                    <a:lnB w="9525">
+                      <a:solidFill>
+                        <a:srgbClr val="EDEDED"/>
+                      </a:solidFill>
+                    </a:lnB>
+                    <a:solidFill>
+                      <a:srgbClr val="FFFFFF"/>
+                    </a:solidFill>
+                  </a:tcPr>
+                </a:tc>
+                <a:tc>
+                  <a:txBody>
+                    <a:bodyPr/>
+                    <a:lstStyle/>
+                    <a:p>
+                      <a:pPr algn="l">
+                        <a:lnSpc>
+                          <a:spcPts val="1575"/>
+                        </a:lnSpc>
+                        <a:spcBef>
+                          <a:spcPts val="0"/>
+                        </a:spcBef>
+                        <a:spcAft>
+                          <a:spcPts val="0"/>
+                        </a:spcAft>
+                      </a:pPr>
+                      <a:r>
+                        <a:rPr sz="1125" b="0">
+                          <a:solidFill>
+                            <a:srgbClr val="666666"/>
+                          </a:solidFill>
+                          <a:latin typeface="Helvetica Neue"/>
+                          <a:ea typeface="Helvetica Neue"/>
+                          <a:cs typeface="Helvetica Neue"/>
+                        </a:rPr>
+                        <a:t>50%</a:t>
+                      </a:r>
+                    </a:p>
+                  </a:txBody>
+                  <a:tcPr marL="114300" marR="114300" marT="123825" marB="123825">
+                    <a:lnL w="0">
+                      <a:noFill/>
+                    </a:lnL>
+                    <a:lnR w="0">
+                      <a:noFill/>
+                    </a:lnR>
+                    <a:lnT w="9525" cap="flat" cmpd="sng" algn="ctr">
+                      <a:solidFill>
+                        <a:srgbClr val="EDEDED"/>
+                      </a:solidFill>
+                      <a:prstDash val="solid"/>
+                      <a:round/>
+                      <a:headEnd type="none" w="med" len="med"/>
+                      <a:tailEnd type="none" w="med" len="med"/>
+                    </a:lnT>
+                    <a:lnB w="9525">
+                      <a:solidFill>
+                        <a:srgbClr val="EDEDED"/>
+                      </a:solidFill>
+                    </a:lnB>
+                    <a:solidFill>
+                      <a:srgbClr val="FFFFFF"/>
+                    </a:solidFill>
+                  </a:tcPr>
+                </a:tc>
+                <a:tc>
+                  <a:txBody>
+                    <a:bodyPr/>
+                    <a:lstStyle/>
+                    <a:p>
+                      <a:pPr algn="l">
+                        <a:lnSpc>
+                          <a:spcPts val="1575"/>
+                        </a:lnSpc>
+                        <a:spcBef>
+                          <a:spcPts val="0"/>
+                        </a:spcBef>
+                        <a:spcAft>
+                          <a:spcPts val="0"/>
+                        </a:spcAft>
+                      </a:pPr>
+                      <a:r>
+                        <a:rPr sz="1125" b="0">
+                          <a:solidFill>
+                            <a:srgbClr val="666666"/>
+                          </a:solidFill>
+                          <a:latin typeface="Helvetica Neue"/>
+                          <a:ea typeface="Helvetica Neue"/>
+                          <a:cs typeface="Helvetica Neue"/>
+                        </a:rPr>
+                        <a:t/>
+                      </a:r>
+                    </a:p>
+                  </a:txBody>
+                  <a:tcPr marL="114300" marR="114300" marT="123825" marB="123825">
+                    <a:lnL w="0">
+                      <a:noFill/>
+                    </a:lnL>
+                    <a:lnR w="0">
+                      <a:noFill/>
+                    </a:lnR>
+                    <a:lnT w="9525" cap="flat" cmpd="sng" algn="ctr">
+                      <a:solidFill>
+                        <a:srgbClr val="EDEDED"/>
+                      </a:solidFill>
+                      <a:prstDash val="solid"/>
+                      <a:round/>
+                      <a:headEnd type="none" w="med" len="med"/>
+                      <a:tailEnd type="none" w="med" len="med"/>
+                    </a:lnT>
+                    <a:lnB w="9525">
+                      <a:solidFill>
+                        <a:srgbClr val="EDEDED"/>
+                      </a:solidFill>
+                    </a:lnB>
+                    <a:solidFill>
+                      <a:srgbClr val="FFFFFF"/>
+                    </a:solidFill>
+                  </a:tcPr>
+                </a:tc>
+                <a:extLst>
+                  <a:ext uri="{0D108BD9-81ED-4DB2-BD59-A6C34878D82A}">
+                    <a16:rowId xmlns:a16="http://schemas.microsoft.com/office/drawing/2014/main" val="10003"/>
+                  </a:ext>
+                </a:extLst>
+              </a:tr>
+              <a:tr h="700000">
+                <a:tc>
+                  <a:txBody>
+                    <a:bodyPr/>
+                    <a:lstStyle/>
+                    <a:p>
+                      <a:pPr algn="l">
+                        <a:lnSpc>
+                          <a:spcPts val="1260"/>
+                        </a:lnSpc>
+                        <a:spcBef>
+                          <a:spcPts val="0"/>
+                        </a:spcBef>
+                        <a:spcAft>
+                          <a:spcPts val="375"/>
+                        </a:spcAft>
+                      </a:pPr>
+                      <a:r>
+                        <a:rPr sz="900" b="1">
+                          <a:solidFill>
+                            <a:srgbClr val="01873F"/>
+                          </a:solidFill>
+                          <a:latin typeface="Helvetica Neue"/>
+                          <a:ea typeface="Helvetica Neue"/>
+                          <a:cs typeface="Helvetica Neue"/>
+                        </a:rPr>
+                        <a:t>Продукт</a:t>
+                      </a:r>
+                    </a:p>
+                    <a:p>
+                      <a:pPr algn="l">
+                        <a:lnSpc>
+                          <a:spcPts val="1575"/>
+                        </a:lnSpc>
+                        <a:spcBef>
+                          <a:spcPts val="0"/>
+                        </a:spcBef>
+                        <a:spcAft>
+                          <a:spcPts val="0"/>
+                        </a:spcAft>
+                      </a:pPr>
+                      <a:r>
+                        <a:rPr sz="1125" b="0">
+                          <a:solidFill>
+                            <a:srgbClr val="666666"/>
+                          </a:solidFill>
+                          <a:latin typeface="Helvetica Neue"/>
+                          <a:ea typeface="Helvetica Neue"/>
+                          <a:cs typeface="Helvetica Neue"/>
+                        </a:rPr>
+                        <a:t>Дом групповых продуктов · Подключения</a:t>
+                      </a:r>
+                    </a:p>
+                  </a:txBody>
+                  <a:tcPr marL="114300" marR="114300" marT="123825" marB="123825">
+                    <a:lnL w="0">
+                      <a:noFill/>
+                    </a:lnL>
+                    <a:lnR w="0">
+                      <a:noFill/>
+                    </a:lnR>
+                    <a:lnT w="9525" cap="flat" cmpd="sng" algn="ctr">
+                      <a:solidFill>
+                        <a:srgbClr val="EDEDED"/>
+                      </a:solidFill>
+                      <a:prstDash val="solid"/>
+                      <a:round/>
+                      <a:headEnd type="none" w="med" len="med"/>
+                      <a:tailEnd type="none" w="med" len="med"/>
+                    </a:lnT>
+                    <a:lnB w="9525">
+                      <a:solidFill>
+                        <a:srgbClr val="EDEDED"/>
+                      </a:solidFill>
+                    </a:lnB>
+                    <a:solidFill>
+                      <a:srgbClr val="FFFFFF"/>
+                    </a:solidFill>
+                  </a:tcPr>
+                </a:tc>
+                <a:tc>
+                  <a:txBody>
+                    <a:bodyPr/>
+                    <a:lstStyle/>
+                    <a:p>
+                      <a:pPr algn="l">
+                        <a:lnSpc>
+                          <a:spcPts val="1575"/>
+                        </a:lnSpc>
+                        <a:spcBef>
+                          <a:spcPts val="0"/>
+                        </a:spcBef>
+                        <a:spcAft>
+                          <a:spcPts val="0"/>
+                        </a:spcAft>
+                      </a:pPr>
+                      <a:r>
+                        <a:rPr sz="1125" b="0">
+                          <a:solidFill>
+                            <a:srgbClr val="666666"/>
+                          </a:solidFill>
+                          <a:latin typeface="Helvetica Neue"/>
+                          <a:ea typeface="Helvetica Neue"/>
+                          <a:cs typeface="Helvetica Neue"/>
+                        </a:rPr>
+                        <a:t>?</a:t>
+                      </a:r>
+                    </a:p>
+                  </a:txBody>
+                  <a:tcPr marL="114300" marR="114300" marT="123825" marB="123825">
+                    <a:lnL w="0">
+                      <a:noFill/>
+                    </a:lnL>
+                    <a:lnR w="0">
+                      <a:noFill/>
+                    </a:lnR>
+                    <a:lnT w="9525" cap="flat" cmpd="sng" algn="ctr">
+                      <a:solidFill>
+                        <a:srgbClr val="EDEDED"/>
+                      </a:solidFill>
+                      <a:prstDash val="solid"/>
+                      <a:round/>
+                      <a:headEnd type="none" w="med" len="med"/>
+                      <a:tailEnd type="none" w="med" len="med"/>
+                    </a:lnT>
+                    <a:lnB w="9525">
+                      <a:solidFill>
+                        <a:srgbClr val="EDEDED"/>
+                      </a:solidFill>
+                    </a:lnB>
+                    <a:solidFill>
+                      <a:srgbClr val="FFFFFF"/>
+                    </a:solidFill>
+                  </a:tcPr>
+                </a:tc>
+                <a:tc>
+                  <a:txBody>
+                    <a:bodyPr/>
+                    <a:lstStyle/>
+                    <a:p>
+                      <a:pPr algn="l">
+                        <a:lnSpc>
+                          <a:spcPts val="1575"/>
+                        </a:lnSpc>
+                        <a:spcBef>
+                          <a:spcPts val="0"/>
+                        </a:spcBef>
+                        <a:spcAft>
+                          <a:spcPts val="0"/>
+                        </a:spcAft>
+                      </a:pPr>
+                      <a:r>
+                        <a:rPr sz="1125" b="0">
+                          <a:solidFill>
+                            <a:srgbClr val="666666"/>
+                          </a:solidFill>
+                          <a:latin typeface="Helvetica Neue"/>
+                          <a:ea typeface="Helvetica Neue"/>
+                          <a:cs typeface="Helvetica Neue"/>
+                        </a:rPr>
+                        <a:t>?</a:t>
+                      </a:r>
+                    </a:p>
+                  </a:txBody>
+                  <a:tcPr marL="114300" marR="114300" marT="123825" marB="123825">
+                    <a:lnL w="0">
+                      <a:noFill/>
+                    </a:lnL>
+                    <a:lnR w="0">
+                      <a:noFill/>
+                    </a:lnR>
+                    <a:lnT w="9525" cap="flat" cmpd="sng" algn="ctr">
+                      <a:solidFill>
+                        <a:srgbClr val="EDEDED"/>
+                      </a:solidFill>
+                      <a:prstDash val="solid"/>
+                      <a:round/>
+                      <a:headEnd type="none" w="med" len="med"/>
+                      <a:tailEnd type="none" w="med" len="med"/>
+                    </a:lnT>
+                    <a:lnB w="9525">
+                      <a:solidFill>
+                        <a:srgbClr val="EDEDED"/>
+                      </a:solidFill>
+                    </a:lnB>
+                    <a:solidFill>
+                      <a:srgbClr val="FFFFFF"/>
+                    </a:solidFill>
+                  </a:tcPr>
+                </a:tc>
+                <a:tc>
+                  <a:txBody>
+                    <a:bodyPr/>
+                    <a:lstStyle/>
+                    <a:p>
+                      <a:pPr algn="l">
+                        <a:lnSpc>
+                          <a:spcPts val="1575"/>
+                        </a:lnSpc>
+                        <a:spcBef>
+                          <a:spcPts val="0"/>
+                        </a:spcBef>
+                        <a:spcAft>
+                          <a:spcPts val="0"/>
+                        </a:spcAft>
+                      </a:pPr>
+                      <a:r>
+                        <a:rPr sz="1125" b="0">
+                          <a:solidFill>
+                            <a:srgbClr val="666666"/>
+                          </a:solidFill>
+                          <a:latin typeface="Helvetica Neue"/>
+                          <a:ea typeface="Helvetica Neue"/>
+                          <a:cs typeface="Helvetica Neue"/>
+                        </a:rPr>
+                        <a:t>?</a:t>
                       </a:r>
                     </a:p>
                   </a:txBody>
@@ -18099,7 +20249,7 @@
         </p:nvGraphicFramePr>
         <p:xfrm>
           <a:off x="457200" y="1752600"/>
-          <a:ext cx="11277600" cy="1727675"/>
+          <a:ext cx="11277600" cy="2880000"/>
         </p:xfrm>
         <a:graphic>
           <a:graphicData uri="http://schemas.openxmlformats.org/drawingml/2006/table">
@@ -18135,7 +20285,7 @@
                   </a:extLst>
                 </a:gridCol>
               </a:tblGrid>
-              <a:tr h="447675">
+              <a:tr h="380000">
                 <a:tc>
                   <a:txBody>
                     <a:bodyPr/>
@@ -18346,7 +20496,7 @@
                   </a:ext>
                 </a:extLst>
               </a:tr>
-              <a:tr h="1280000">
+              <a:tr h="1000000">
                 <a:tc>
                   <a:txBody>
                     <a:bodyPr/>
@@ -18507,6 +20657,257 @@
                           <a:cs typeface="Helvetica Neue"/>
                         </a:rPr>
                         <a:t>Витрина в приложении и лендинг на сайте к старту РК 21.09. Точки входа: виджет на главной и блок в «Услугах». Выбор: опция на 30 дней или разовое ускорение на Х часов.</a:t>
+                      </a:r>
+                    </a:p>
+                  </a:txBody>
+                  <a:tcPr marL="114300" marR="114300" marT="123825" marB="123825">
+                    <a:lnL w="0">
+                      <a:noFill/>
+                    </a:lnL>
+                    <a:lnR w="0">
+                      <a:noFill/>
+                    </a:lnR>
+                    <a:lnT w="9525" cap="flat" cmpd="sng" algn="ctr">
+                      <a:solidFill>
+                        <a:srgbClr val="EDEDED"/>
+                      </a:solidFill>
+                      <a:prstDash val="solid"/>
+                      <a:round/>
+                      <a:headEnd type="none" w="med" len="med"/>
+                      <a:tailEnd type="none" w="med" len="med"/>
+                    </a:lnT>
+                    <a:lnB w="9525">
+                      <a:solidFill>
+                        <a:srgbClr val="EDEDED"/>
+                      </a:solidFill>
+                    </a:lnB>
+                    <a:solidFill>
+                      <a:srgbClr val="FFFFFF"/>
+                    </a:solidFill>
+                  </a:tcPr>
+                </a:tc>
+                <a:tc>
+                  <a:txBody>
+                    <a:bodyPr/>
+                    <a:lstStyle/>
+                    <a:p>
+                      <a:pPr algn="l">
+                        <a:lnSpc>
+                          <a:spcPts val="1575"/>
+                        </a:lnSpc>
+                        <a:spcBef>
+                          <a:spcPts val="0"/>
+                        </a:spcBef>
+                        <a:spcAft>
+                          <a:spcPts val="0"/>
+                        </a:spcAft>
+                      </a:pPr>
+                      <a:r>
+                        <a:rPr sz="1125" b="0">
+                          <a:solidFill>
+                            <a:srgbClr val="666666"/>
+                          </a:solidFill>
+                          <a:latin typeface="Helvetica Neue"/>
+                          <a:ea typeface="Helvetica Neue"/>
+                          <a:cs typeface="Helvetica Neue"/>
+                        </a:rPr>
+                        <a:t>Поставлено</a:t>
+                      </a:r>
+                    </a:p>
+                  </a:txBody>
+                  <a:tcPr marL="114300" marR="114300" marT="123825" marB="123825">
+                    <a:lnL w="0">
+                      <a:noFill/>
+                    </a:lnL>
+                    <a:lnR w="0">
+                      <a:noFill/>
+                    </a:lnR>
+                    <a:lnT w="9525" cap="flat" cmpd="sng" algn="ctr">
+                      <a:solidFill>
+                        <a:srgbClr val="EDEDED"/>
+                      </a:solidFill>
+                      <a:prstDash val="solid"/>
+                      <a:round/>
+                      <a:headEnd type="none" w="med" len="med"/>
+                      <a:tailEnd type="none" w="med" len="med"/>
+                    </a:lnT>
+                    <a:lnB w="9525">
+                      <a:solidFill>
+                        <a:srgbClr val="EDEDED"/>
+                      </a:solidFill>
+                    </a:lnB>
+                    <a:solidFill>
+                      <a:srgbClr val="FFFFFF"/>
+                    </a:solidFill>
+                  </a:tcPr>
+                </a:tc>
+                <a:extLst>
+                  <a:ext uri="{0D108BD9-81ED-4DB2-BD59-A6C34878D82A}">
+                    <a16:rowId xmlns:a16="http://schemas.microsoft.com/office/drawing/2014/main" val="10001"/>
+                  </a:ext>
+                </a:extLst>
+              </a:tr>
+              <a:tr h="1500000">
+                <a:tc>
+                  <a:txBody>
+                    <a:bodyPr/>
+                    <a:lstStyle/>
+                    <a:p>
+                      <a:pPr algn="l">
+                        <a:lnSpc>
+                          <a:spcPts val="1575"/>
+                        </a:lnSpc>
+                        <a:spcBef>
+                          <a:spcPts val="0"/>
+                        </a:spcBef>
+                        <a:spcAft>
+                          <a:spcPts val="0"/>
+                        </a:spcAft>
+                      </a:pPr>
+                      <a:r>
+                        <a:rPr sz="1125" b="0">
+                          <a:solidFill>
+                            <a:srgbClr val="333333"/>
+                          </a:solidFill>
+                          <a:latin typeface="Helvetica Neue"/>
+                          <a:ea typeface="Helvetica Neue"/>
+                          <a:cs typeface="Helvetica Neue"/>
+                        </a:rPr>
+                        <a:t>Продуктовый</a:t>
+                      </a:r>
+                    </a:p>
+                    <a:p>
+                      <a:pPr algn="l">
+                        <a:lnSpc>
+                          <a:spcPts val="1575"/>
+                        </a:lnSpc>
+                        <a:spcBef>
+                          <a:spcPts val="0"/>
+                        </a:spcBef>
+                        <a:spcAft>
+                          <a:spcPts val="0"/>
+                        </a:spcAft>
+                      </a:pPr>
+                      <a:r>
+                        <a:rPr sz="1125" b="0">
+                          <a:solidFill>
+                            <a:srgbClr val="333333"/>
+                          </a:solidFill>
+                          <a:latin typeface="Helvetica Neue"/>
+                          <a:ea typeface="Helvetica Neue"/>
+                          <a:cs typeface="Helvetica Neue"/>
+                        </a:rPr>
+                        <a:t>МегаСемья 2.0</a:t>
+                      </a:r>
+                    </a:p>
+                  </a:txBody>
+                  <a:tcPr marL="114300" marR="114300" marT="123825" marB="123825">
+                    <a:lnL w="0">
+                      <a:noFill/>
+                    </a:lnL>
+                    <a:lnR w="0">
+                      <a:noFill/>
+                    </a:lnR>
+                    <a:lnT w="9525" cap="flat" cmpd="sng" algn="ctr">
+                      <a:solidFill>
+                        <a:srgbClr val="EDEDED"/>
+                      </a:solidFill>
+                      <a:prstDash val="solid"/>
+                      <a:round/>
+                      <a:headEnd type="none" w="med" len="med"/>
+                      <a:tailEnd type="none" w="med" len="med"/>
+                    </a:lnT>
+                    <a:lnB w="9525">
+                      <a:solidFill>
+                        <a:srgbClr val="EDEDED"/>
+                      </a:solidFill>
+                    </a:lnB>
+                    <a:solidFill>
+                      <a:srgbClr val="FFFFFF"/>
+                    </a:solidFill>
+                  </a:tcPr>
+                </a:tc>
+                <a:tc>
+                  <a:txBody>
+                    <a:bodyPr/>
+                    <a:lstStyle/>
+                    <a:p>
+                      <a:pPr algn="l">
+                        <a:lnSpc>
+                          <a:spcPts val="1575"/>
+                        </a:lnSpc>
+                        <a:spcBef>
+                          <a:spcPts val="0"/>
+                        </a:spcBef>
+                        <a:spcAft>
+                          <a:spcPts val="0"/>
+                        </a:spcAft>
+                      </a:pPr>
+                      <a:r>
+                        <a:rPr sz="1125" b="0">
+                          <a:solidFill>
+                            <a:srgbClr val="666666"/>
+                          </a:solidFill>
+                          <a:latin typeface="Helvetica Neue"/>
+                          <a:ea typeface="Helvetica Neue"/>
+                          <a:cs typeface="Helvetica Neue"/>
+                        </a:rPr>
+                        <a:t>Запустить mvp-версию МегаСемьи 2.0 к рекламной компании 21.07</a:t>
+                      </a:r>
+                    </a:p>
+                  </a:txBody>
+                  <a:tcPr marL="114300" marR="114300" marT="123825" marB="123825">
+                    <a:lnL w="0">
+                      <a:noFill/>
+                    </a:lnL>
+                    <a:lnR w="0">
+                      <a:noFill/>
+                    </a:lnR>
+                    <a:lnT w="9525" cap="flat" cmpd="sng" algn="ctr">
+                      <a:solidFill>
+                        <a:srgbClr val="EDEDED"/>
+                      </a:solidFill>
+                      <a:prstDash val="solid"/>
+                      <a:round/>
+                      <a:headEnd type="none" w="med" len="med"/>
+                      <a:tailEnd type="none" w="med" len="med"/>
+                    </a:lnT>
+                    <a:lnB w="9525">
+                      <a:solidFill>
+                        <a:srgbClr val="EDEDED"/>
+                      </a:solidFill>
+                    </a:lnB>
+                    <a:solidFill>
+                      <a:srgbClr val="FFFFFF"/>
+                    </a:solidFill>
+                  </a:tcPr>
+                </a:tc>
+                <a:tc>
+                  <a:txBody>
+                    <a:bodyPr/>
+                    <a:lstStyle/>
+                    <a:p>
+                      <a:pPr algn="l">
+                        <a:lnSpc>
+                          <a:spcPts val="1575"/>
+                        </a:lnSpc>
+                        <a:spcBef>
+                          <a:spcPts val="0"/>
+                        </a:spcBef>
+                        <a:spcAft>
+                          <a:spcPts val="0"/>
+                        </a:spcAft>
+                      </a:pPr>
+                      <a:r>
+                        <a:rPr sz="1125" b="0">
+                          <a:solidFill>
+                            <a:srgbClr val="666666"/>
+                          </a:solidFill>
+                          <a:latin typeface="Helvetica Neue"/>
+                          <a:ea typeface="Helvetica Neue"/>
+                          <a:cs typeface="Helvetica Neue"/>
+                        </a:rPr>
+                        <a:t>Запустили семейную платформу с расширенным набором опций по управлению номерами близких. Каждому члену семьи можно назначить персональную роль, готовые настройки которой соответствуют запросам на безопасность и заботу о близких. Релиз 23.07.2026.</a:t>
                       </a:r>
                     </a:p>
                   </a:txBody>
@@ -18617,8 +21018,8 @@
         </p:nvSpPr>
         <p:spPr>
           <a:xfrm>
-            <a:off x="2912990" y="3644867"/>
-            <a:ext cx="8821810" cy="800100"/>
+            <a:off x="2159552" y="4772600"/>
+            <a:ext cx="9575248" cy="720000"/>
           </a:xfrm>
           <a:prstGeom prst="rect">
             <a:avLst/>
@@ -18674,8 +21075,8 @@
         </p:blipFill>
         <p:spPr>
           <a:xfrm>
-            <a:off x="457200" y="3644867"/>
-            <a:ext cx="990151" cy="2148840"/>
+            <a:off x="457200" y="4772600"/>
+            <a:ext cx="691176" cy="1500000"/>
           </a:xfrm>
           <a:prstGeom prst="rect">
             <a:avLst/>
@@ -18698,8 +21099,8 @@
         </p:blipFill>
         <p:spPr>
           <a:xfrm>
-            <a:off x="1593655" y="3644867"/>
-            <a:ext cx="990151" cy="2148840"/>
+            <a:off x="1288376" y="4772600"/>
+            <a:ext cx="691176" cy="1500000"/>
           </a:xfrm>
           <a:prstGeom prst="rect">
             <a:avLst/>
@@ -18720,6 +21121,477 @@
 </file>
 
 <file path=ppt/slides/slide6.xml><?xml version="1.0" encoding="utf-8"?>
+<p:sld xmlns:a="http://schemas.openxmlformats.org/drawingml/2006/main" xmlns:p="http://schemas.openxmlformats.org/presentationml/2006/main" xmlns:r="http://schemas.openxmlformats.org/officeDocument/2006/relationships">
+  <p:cSld>
+    <p:spTree>
+      <p:nvGrpSpPr>
+        <p:cNvPr id="1" name=""/>
+        <p:cNvGrpSpPr/>
+        <p:nvPr/>
+      </p:nvGrpSpPr>
+      <p:grpSpPr/>
+      <p:sp>
+        <p:nvSpPr>
+          <p:cNvPr id="12" name="section">
+            <a:extLst>
+              <a:ext uri="{FF2B5EF4-FFF2-40B4-BE49-F238E27FC236}">
+                <a16:creationId xmlns:a16="http://schemas.microsoft.com/office/drawing/2014/main" id="{9E516BAD-AC21-428E-ADC1-EB1E8D2ADB0B}"/>
+              </a:ext>
+            </a:extLst>
+          </p:cNvPr>
+          <p:cNvSpPr>
+            <a:spLocks noGrp="1"/>
+          </p:cNvSpPr>
+          <p:nvPr/>
+        </p:nvSpPr>
+        <p:spPr>
+          <a:xfrm>
+            <a:off x="457200" y="257175"/>
+            <a:ext cx="7572375" cy="209550"/>
+          </a:xfrm>
+          <a:prstGeom prst="rect">
+            <a:avLst/>
+          </a:prstGeom>
+          <a:noFill/>
+          <a:ln w="0">
+            <a:noFill/>
+          </a:ln>
+        </p:spPr>
+        <p:txBody>
+          <a:bodyPr wrap="square" lIns="0" tIns="0" rIns="0" bIns="0" anchor="t">
+            <a:noAutofit/>
+          </a:bodyPr>
+          <a:lstStyle/>
+          <a:p>
+            <a:pPr algn="l">
+              <a:defRPr sz="900" b="1">
+                <a:solidFill>
+                  <a:srgbClr val="01873F"/>
+                </a:solidFill>
+                <a:latin typeface="Helvetica Neue"/>
+                <a:ea typeface="Helvetica Neue"/>
+                <a:cs typeface="Helvetica Neue"/>
+              </a:defRPr>
+            </a:pPr>
+            <a:r>
+              <a:rPr sz="900" b="1">
+                <a:solidFill>
+                  <a:srgbClr val="01873F"/>
+                </a:solidFill>
+                <a:latin typeface="Helvetica Neue"/>
+                <a:ea typeface="Helvetica Neue"/>
+                <a:cs typeface="Helvetica Neue"/>
+              </a:rPr>
+              <a:t>Телеком · Демо Q3</a:t>
+            </a:r>
+          </a:p>
+        </p:txBody>
+      </p:sp>
+      <p:sp>
+        <p:nvSpPr>
+          <p:cNvPr id="2" name="context">
+            <a:extLst>
+              <a:ext uri="{FF2B5EF4-FFF2-40B4-BE49-F238E27FC236}">
+                <a16:creationId xmlns:a16="http://schemas.microsoft.com/office/drawing/2014/main" id="{11065353-9CF7-4A8F-B620-83F0709BB55B}"/>
+              </a:ext>
+            </a:extLst>
+          </p:cNvPr>
+          <p:cNvSpPr>
+            <a:spLocks noGrp="1"/>
+          </p:cNvSpPr>
+          <p:nvPr/>
+        </p:nvSpPr>
+        <p:spPr>
+          <a:xfrm>
+            <a:off x="8058150" y="257175"/>
+            <a:ext cx="3676650" cy="228600"/>
+          </a:xfrm>
+          <a:prstGeom prst="rect">
+            <a:avLst/>
+          </a:prstGeom>
+          <a:noFill/>
+          <a:ln w="0">
+            <a:noFill/>
+          </a:ln>
+        </p:spPr>
+        <p:txBody>
+          <a:bodyPr wrap="square" lIns="0" tIns="0" rIns="0" bIns="0" anchor="t">
+            <a:noAutofit/>
+          </a:bodyPr>
+          <a:lstStyle/>
+          <a:p>
+            <a:pPr algn="r">
+              <a:defRPr sz="900" b="0">
+                <a:solidFill>
+                  <a:srgbClr val="5F5F5F"/>
+                </a:solidFill>
+                <a:latin typeface="Helvetica Neue"/>
+                <a:ea typeface="Helvetica Neue"/>
+                <a:cs typeface="Helvetica Neue"/>
+              </a:defRPr>
+            </a:pPr>
+            <a:r>
+              <a:rPr sz="900" b="0">
+                <a:solidFill>
+                  <a:srgbClr val="5F5F5F"/>
+                </a:solidFill>
+                <a:latin typeface="Helvetica Neue"/>
+                <a:ea typeface="Helvetica Neue"/>
+                <a:cs typeface="Helvetica Neue"/>
+              </a:rPr>
+              <a:t>Релиз 23.07.2026</a:t>
+            </a:r>
+          </a:p>
+        </p:txBody>
+      </p:sp>
+      <p:sp>
+        <p:nvSpPr>
+          <p:cNvPr id="3" name="title">
+            <a:extLst>
+              <a:ext uri="{FF2B5EF4-FFF2-40B4-BE49-F238E27FC236}">
+                <a16:creationId xmlns:a16="http://schemas.microsoft.com/office/drawing/2014/main" id="{CD653E68-CC07-4D12-8EE0-E37A7ED2F0F6}"/>
+              </a:ext>
+            </a:extLst>
+          </p:cNvPr>
+          <p:cNvSpPr>
+            <a:spLocks noGrp="1"/>
+          </p:cNvSpPr>
+          <p:nvPr/>
+        </p:nvSpPr>
+        <p:spPr>
+          <a:xfrm>
+            <a:off x="457200" y="657225"/>
+            <a:ext cx="11277600" cy="381000"/>
+          </a:xfrm>
+          <a:prstGeom prst="rect">
+            <a:avLst/>
+          </a:prstGeom>
+          <a:noFill/>
+          <a:ln w="0">
+            <a:noFill/>
+          </a:ln>
+        </p:spPr>
+        <p:txBody>
+          <a:bodyPr wrap="square" lIns="0" tIns="0" rIns="0" bIns="0" anchor="t">
+            <a:noAutofit/>
+          </a:bodyPr>
+          <a:lstStyle/>
+          <a:p>
+            <a:pPr algn="l">
+              <a:defRPr sz="2400" b="1">
+                <a:solidFill>
+                  <a:srgbClr val="333333"/>
+                </a:solidFill>
+                <a:latin typeface="Helvetica Neue"/>
+                <a:ea typeface="Helvetica Neue"/>
+                <a:cs typeface="Helvetica Neue"/>
+              </a:defRPr>
+            </a:pPr>
+            <a:r>
+              <a:rPr sz="2400" b="1">
+                <a:solidFill>
+                  <a:srgbClr val="333333"/>
+                </a:solidFill>
+                <a:latin typeface="Helvetica Neue"/>
+                <a:ea typeface="Helvetica Neue"/>
+                <a:cs typeface="Helvetica Neue"/>
+              </a:rPr>
+              <a:t>Экраны МегаСемьи 2.0</a:t>
+            </a:r>
+          </a:p>
+        </p:txBody>
+      </p:sp>
+      <p:sp>
+        <p:nvSpPr>
+          <p:cNvPr id="4" name="footer-rule">
+            <a:extLst>
+              <a:ext uri="{FF2B5EF4-FFF2-40B4-BE49-F238E27FC236}">
+                <a16:creationId xmlns:a16="http://schemas.microsoft.com/office/drawing/2014/main" id="{1B66E779-8612-4A79-91C5-2D4F0487529D}"/>
+              </a:ext>
+            </a:extLst>
+          </p:cNvPr>
+          <p:cNvSpPr>
+            <a:spLocks noGrp="1"/>
+          </p:cNvSpPr>
+          <p:nvPr/>
+        </p:nvSpPr>
+        <p:spPr>
+          <a:xfrm>
+            <a:off x="457200" y="6467475"/>
+            <a:ext cx="11277600" cy="0"/>
+          </a:xfrm>
+          <a:prstGeom prst="line">
+            <a:avLst/>
+          </a:prstGeom>
+          <a:noFill/>
+          <a:ln w="9525">
+            <a:solidFill>
+              <a:srgbClr val="EDEDED"/>
+            </a:solidFill>
+            <a:prstDash val="solid"/>
+          </a:ln>
+        </p:spPr>
+        <p:txBody>
+          <a:bodyPr/>
+          <a:lstStyle/>
+          <a:p>
+            <a:endParaRPr lang="en-JP"/>
+          </a:p>
+        </p:txBody>
+      </p:sp>
+      <p:sp>
+        <p:nvSpPr>
+          <p:cNvPr id="5" name="footer-reference">
+            <a:hlinkClick r:id="rId3" action="ppaction://hlinksldjump"/>
+            <a:extLst>
+              <a:ext uri="{FF2B5EF4-FFF2-40B4-BE49-F238E27FC236}">
+                <a16:creationId xmlns:a16="http://schemas.microsoft.com/office/drawing/2014/main" id="{A144CE90-B6FD-421A-A2FC-A83FDC78F90E}"/>
+              </a:ext>
+            </a:extLst>
+          </p:cNvPr>
+          <p:cNvSpPr>
+            <a:spLocks noGrp="1"/>
+          </p:cNvSpPr>
+          <p:nvPr/>
+        </p:nvSpPr>
+        <p:spPr>
+          <a:xfrm>
+            <a:off x="457200" y="6591300"/>
+            <a:ext cx="10001250" cy="180975"/>
+          </a:xfrm>
+          <a:prstGeom prst="rect">
+            <a:avLst/>
+          </a:prstGeom>
+          <a:noFill/>
+          <a:ln w="0">
+            <a:noFill/>
+          </a:ln>
+        </p:spPr>
+        <p:txBody>
+          <a:bodyPr wrap="square" lIns="0" tIns="0" rIns="0" bIns="0" anchor="t">
+            <a:noAutofit/>
+          </a:bodyPr>
+          <a:lstStyle/>
+          <a:p>
+            <a:pPr algn="l">
+              <a:defRPr sz="900" b="0">
+                <a:solidFill>
+                  <a:srgbClr val="731982"/>
+                </a:solidFill>
+                <a:latin typeface="Helvetica Neue"/>
+                <a:ea typeface="Helvetica Neue"/>
+                <a:cs typeface="Helvetica Neue"/>
+              </a:defRPr>
+            </a:pPr>
+            <a:r>
+              <a:rPr sz="900" b="0" u="sng">
+                <a:solidFill>
+                  <a:srgbClr val="731982"/>
+                </a:solidFill>
+                <a:latin typeface="Helvetica Neue"/>
+                <a:ea typeface="Helvetica Neue"/>
+                <a:cs typeface="Helvetica Neue"/>
+              </a:rPr>
+              <a:t>К результату Q3 · стр. 05</a:t>
+            </a:r>
+          </a:p>
+        </p:txBody>
+      </p:sp>
+      <p:sp>
+        <p:nvSpPr>
+          <p:cNvPr id="6" name="page">
+            <a:extLst>
+              <a:ext uri="{FF2B5EF4-FFF2-40B4-BE49-F238E27FC236}">
+                <a16:creationId xmlns:a16="http://schemas.microsoft.com/office/drawing/2014/main" id="{B9C26502-111F-4FD7-85AA-06B1321BAEB2}"/>
+              </a:ext>
+            </a:extLst>
+          </p:cNvPr>
+          <p:cNvSpPr>
+            <a:spLocks noGrp="1"/>
+          </p:cNvSpPr>
+          <p:nvPr/>
+        </p:nvSpPr>
+        <p:spPr>
+          <a:xfrm>
+            <a:off x="10725150" y="6591300"/>
+            <a:ext cx="1009650" cy="180975"/>
+          </a:xfrm>
+          <a:prstGeom prst="rect">
+            <a:avLst/>
+          </a:prstGeom>
+          <a:noFill/>
+          <a:ln w="0">
+            <a:noFill/>
+          </a:ln>
+        </p:spPr>
+        <p:txBody>
+          <a:bodyPr wrap="square" lIns="0" tIns="0" rIns="0" bIns="0" anchor="t">
+            <a:noAutofit/>
+          </a:bodyPr>
+          <a:lstStyle/>
+          <a:p>
+            <a:pPr algn="r">
+              <a:defRPr sz="900" b="0">
+                <a:solidFill>
+                  <a:srgbClr val="5F5F5F"/>
+                </a:solidFill>
+                <a:latin typeface="Helvetica Neue"/>
+                <a:ea typeface="Helvetica Neue"/>
+                <a:cs typeface="Helvetica Neue"/>
+              </a:defRPr>
+            </a:pPr>
+            <a:r>
+              <a:rPr sz="900" b="0">
+                <a:solidFill>
+                  <a:srgbClr val="5F5F5F"/>
+                </a:solidFill>
+                <a:latin typeface="Helvetica Neue"/>
+                <a:ea typeface="Helvetica Neue"/>
+                <a:cs typeface="Helvetica Neue"/>
+              </a:rPr>
+              <a:t>демо</a:t>
+            </a:r>
+          </a:p>
+        </p:txBody>
+      </p:sp>
+      <p:sp>
+        <p:nvSpPr>
+          <p:cNvPr id="13" name="intro">
+            <a:extLst>
+              <a:ext uri="{FF2B5EF4-FFF2-40B4-BE49-F238E27FC236}">
+                <a16:creationId xmlns:a16="http://schemas.microsoft.com/office/drawing/2014/main" id="{8B07A0F0-E87F-46FB-BE33-5BDEE2AF6BC6}"/>
+              </a:ext>
+            </a:extLst>
+          </p:cNvPr>
+          <p:cNvSpPr>
+            <a:spLocks noGrp="1"/>
+          </p:cNvSpPr>
+          <p:nvPr/>
+        </p:nvSpPr>
+        <p:spPr>
+          <a:xfrm>
+            <a:off x="457200" y="1200150"/>
+            <a:ext cx="11277600" cy="495300"/>
+          </a:xfrm>
+          <a:prstGeom prst="rect">
+            <a:avLst/>
+          </a:prstGeom>
+          <a:noFill/>
+          <a:ln w="0">
+            <a:noFill/>
+          </a:ln>
+        </p:spPr>
+        <p:txBody>
+          <a:bodyPr wrap="square" lIns="0" tIns="0" rIns="0" bIns="0" anchor="t">
+            <a:noAutofit/>
+          </a:bodyPr>
+          <a:lstStyle/>
+          <a:p>
+            <a:pPr algn="l">
+              <a:defRPr sz="1275" b="0">
+                <a:solidFill>
+                  <a:srgbClr val="5F5F5F"/>
+                </a:solidFill>
+                <a:latin typeface="Helvetica Neue"/>
+                <a:ea typeface="Helvetica Neue"/>
+                <a:cs typeface="Helvetica Neue"/>
+              </a:defRPr>
+            </a:pPr>
+            <a:r>
+              <a:rPr sz="1275" b="0">
+                <a:solidFill>
+                  <a:srgbClr val="5F5F5F"/>
+                </a:solidFill>
+                <a:latin typeface="Helvetica Neue"/>
+                <a:ea typeface="Helvetica Neue"/>
+                <a:cs typeface="Helvetica Neue"/>
+              </a:rPr>
+              <a:t>Приглашение и выбор роли, назначение роли и группа «МегаСемья». Номера и имена с макетов в таблицы не вынесены.</a:t>
+            </a:r>
+          </a:p>
+        </p:txBody>
+      </p:sp>
+      <p:pic>
+        <p:nvPicPr>
+          <p:cNvPr id="14" name="Picture 13" descr="pic1.png"/>
+          <p:cNvPicPr>
+            <a:picLocks noChangeAspect="1"/>
+          </p:cNvPicPr>
+          <p:nvPr/>
+        </p:nvPicPr>
+        <p:blipFill>
+          <a:blip r:embed="rId2"/>
+          <a:stretch>
+            <a:fillRect/>
+          </a:stretch>
+        </p:blipFill>
+        <p:spPr>
+          <a:xfrm>
+            <a:off x="457200" y="1750000"/>
+            <a:ext cx="1995073" cy="4500000"/>
+          </a:xfrm>
+          <a:prstGeom prst="rect">
+            <a:avLst/>
+          </a:prstGeom>
+        </p:spPr>
+      </p:pic>
+      <p:pic>
+        <p:nvPicPr>
+          <p:cNvPr id="15" name="Picture 14" descr="pic2.png"/>
+          <p:cNvPicPr>
+            <a:picLocks noChangeAspect="1"/>
+          </p:cNvPicPr>
+          <p:nvPr/>
+        </p:nvPicPr>
+        <p:blipFill>
+          <a:blip r:embed="rId3"/>
+          <a:stretch>
+            <a:fillRect/>
+          </a:stretch>
+        </p:blipFill>
+        <p:spPr>
+          <a:xfrm>
+            <a:off x="2612273" y="1750000"/>
+            <a:ext cx="1541389" cy="4500000"/>
+          </a:xfrm>
+          <a:prstGeom prst="rect">
+            <a:avLst/>
+          </a:prstGeom>
+        </p:spPr>
+      </p:pic>
+      <p:pic>
+        <p:nvPicPr>
+          <p:cNvPr id="16" name="Picture 15" descr="pic3.png"/>
+          <p:cNvPicPr>
+            <a:picLocks noChangeAspect="1"/>
+          </p:cNvPicPr>
+          <p:nvPr/>
+        </p:nvPicPr>
+        <p:blipFill>
+          <a:blip r:embed="rId4"/>
+          <a:stretch>
+            <a:fillRect/>
+          </a:stretch>
+        </p:blipFill>
+        <p:spPr>
+          <a:xfrm>
+            <a:off x="4313662" y="1750000"/>
+            <a:ext cx="2263359" cy="4500000"/>
+          </a:xfrm>
+          <a:prstGeom prst="rect">
+            <a:avLst/>
+          </a:prstGeom>
+        </p:spPr>
+      </p:pic>
+    </p:spTree>
+  </p:cSld>
+  <p:clrMapOvr>
+    <a:masterClrMapping/>
+  </p:clrMapOvr>
+</p:sld>
+</file>
+
+<file path=ppt/slides/slide7.xml><?xml version="1.0" encoding="utf-8"?>
 <p:sld xmlns:a="http://schemas.openxmlformats.org/drawingml/2006/main" xmlns:r="http://schemas.openxmlformats.org/officeDocument/2006/relationships" xmlns:p="http://schemas.openxmlformats.org/presentationml/2006/main">
   <p:cSld>
     <p:bg>
@@ -19807,7 +22679,7 @@
 </p:sld>
 </file>
 
-<file path=ppt/slides/slide7.xml><?xml version="1.0" encoding="utf-8"?>
+<file path=ppt/slides/slide8.xml><?xml version="1.0" encoding="utf-8"?>
 <p:sld xmlns:a="http://schemas.openxmlformats.org/drawingml/2006/main" xmlns:r="http://schemas.openxmlformats.org/officeDocument/2006/relationships" xmlns:p="http://schemas.openxmlformats.org/presentationml/2006/main">
   <p:cSld>
     <p:bg>
@@ -21603,7 +24475,7 @@
 </p:sld>
 </file>
 
-<file path=ppt/slides/slide8.xml><?xml version="1.0" encoding="utf-8"?>
+<file path=ppt/slides/slide9.xml><?xml version="1.0" encoding="utf-8"?>
 <p:sld xmlns:a="http://schemas.openxmlformats.org/drawingml/2006/main" xmlns:r="http://schemas.openxmlformats.org/officeDocument/2006/relationships" xmlns:p="http://schemas.openxmlformats.org/presentationml/2006/main">
   <p:cSld>
     <p:spTree>
@@ -21695,1425 +24567,6 @@
     <p:extLst>
       <p:ext uri="{BB962C8B-B14F-4D97-AF65-F5344CB8AC3E}">
         <p14:creationId xmlns:p14="http://schemas.microsoft.com/office/powerpoint/2010/main" val="2922270121"/>
-      </p:ext>
-    </p:extLst>
-  </p:cSld>
-  <p:clrMapOvr>
-    <a:masterClrMapping/>
-  </p:clrMapOvr>
-</p:sld>
-</file>
-
-<file path=ppt/slides/slide9.xml><?xml version="1.0" encoding="utf-8"?>
-<p:sld xmlns:a="http://schemas.openxmlformats.org/drawingml/2006/main" xmlns:r="http://schemas.openxmlformats.org/officeDocument/2006/relationships" xmlns:p="http://schemas.openxmlformats.org/presentationml/2006/main">
-  <p:cSld>
-    <p:bg>
-      <p:bgPr>
-        <a:solidFill>
-          <a:srgbClr val="FFFFFF"/>
-        </a:solidFill>
-        <a:effectLst/>
-      </p:bgPr>
-    </p:bg>
-    <p:spTree>
-      <p:nvGrpSpPr>
-        <p:cNvPr id="1" name=""/>
-        <p:cNvGrpSpPr/>
-        <p:nvPr/>
-      </p:nvGrpSpPr>
-      <p:grpSpPr>
-        <a:xfrm>
-          <a:off x="0" y="0"/>
-          <a:ext cx="0" cy="0"/>
-          <a:chOff x="0" y="0"/>
-          <a:chExt cx="0" cy="0"/>
-        </a:xfrm>
-      </p:grpSpPr>
-      <p:sp>
-        <p:nvSpPr>
-          <p:cNvPr id="18" name="section">
-            <a:extLst>
-              <a:ext uri="{FF2B5EF4-FFF2-40B4-BE49-F238E27FC236}">
-                <a16:creationId xmlns:a16="http://schemas.microsoft.com/office/drawing/2014/main" id="{61FB8580-4ADC-4C1E-B3FC-0D72A5508B0D}"/>
-              </a:ext>
-            </a:extLst>
-          </p:cNvPr>
-          <p:cNvSpPr>
-            <a:spLocks noGrp="1"/>
-          </p:cNvSpPr>
-          <p:nvPr/>
-        </p:nvSpPr>
-        <p:spPr>
-          <a:xfrm>
-            <a:off x="457200" y="257175"/>
-            <a:ext cx="7572375" cy="209550"/>
-          </a:xfrm>
-          <a:prstGeom prst="rect">
-            <a:avLst/>
-          </a:prstGeom>
-          <a:noFill/>
-          <a:ln w="0">
-            <a:noFill/>
-          </a:ln>
-        </p:spPr>
-        <p:txBody>
-          <a:bodyPr wrap="square" lIns="0" tIns="0" rIns="0" bIns="0" anchor="t">
-            <a:noAutofit/>
-          </a:bodyPr>
-          <a:lstStyle/>
-          <a:p>
-            <a:pPr algn="l">
-              <a:defRPr sz="900" b="1">
-                <a:solidFill>
-                  <a:srgbClr val="731982"/>
-                </a:solidFill>
-                <a:latin typeface="Helvetica Neue"/>
-                <a:ea typeface="Helvetica Neue"/>
-                <a:cs typeface="Helvetica Neue"/>
-              </a:defRPr>
-            </a:pPr>
-            <a:r>
-              <a:rPr sz="900" b="1">
-                <a:solidFill>
-                  <a:srgbClr val="731982"/>
-                </a:solidFill>
-                <a:latin typeface="Helvetica Neue"/>
-                <a:ea typeface="Helvetica Neue"/>
-                <a:cs typeface="Helvetica Neue"/>
-              </a:rPr>
-              <a:t>Бэкап · Пример к шаблону 02</a:t>
-            </a:r>
-          </a:p>
-        </p:txBody>
-      </p:sp>
-      <p:sp>
-        <p:nvSpPr>
-          <p:cNvPr id="2" name="context">
-            <a:extLst>
-              <a:ext uri="{FF2B5EF4-FFF2-40B4-BE49-F238E27FC236}">
-                <a16:creationId xmlns:a16="http://schemas.microsoft.com/office/drawing/2014/main" id="{74873236-E01F-4863-8FD0-76214759F244}"/>
-              </a:ext>
-            </a:extLst>
-          </p:cNvPr>
-          <p:cNvSpPr>
-            <a:spLocks noGrp="1"/>
-          </p:cNvSpPr>
-          <p:nvPr/>
-        </p:nvSpPr>
-        <p:spPr>
-          <a:xfrm>
-            <a:off x="8058150" y="257175"/>
-            <a:ext cx="3676650" cy="228600"/>
-          </a:xfrm>
-          <a:prstGeom prst="rect">
-            <a:avLst/>
-          </a:prstGeom>
-          <a:noFill/>
-          <a:ln w="0">
-            <a:noFill/>
-          </a:ln>
-        </p:spPr>
-        <p:txBody>
-          <a:bodyPr wrap="square" lIns="0" tIns="0" rIns="0" bIns="0" anchor="t">
-            <a:noAutofit/>
-          </a:bodyPr>
-          <a:lstStyle/>
-          <a:p>
-            <a:pPr algn="r">
-              <a:defRPr sz="900" b="1">
-                <a:solidFill>
-                  <a:srgbClr val="731982"/>
-                </a:solidFill>
-                <a:latin typeface="Helvetica Neue"/>
-                <a:ea typeface="Helvetica Neue"/>
-                <a:cs typeface="Helvetica Neue"/>
-              </a:defRPr>
-            </a:pPr>
-            <a:r>
-              <a:rPr sz="900" b="1">
-                <a:solidFill>
-                  <a:srgbClr val="731982"/>
-                </a:solidFill>
-                <a:latin typeface="Helvetica Neue"/>
-                <a:ea typeface="Helvetica Neue"/>
-                <a:cs typeface="Helvetica Neue"/>
-              </a:rPr>
-              <a:t>Условный пример</a:t>
-            </a:r>
-          </a:p>
-        </p:txBody>
-      </p:sp>
-      <p:sp>
-        <p:nvSpPr>
-          <p:cNvPr id="3" name="title">
-            <a:extLst>
-              <a:ext uri="{FF2B5EF4-FFF2-40B4-BE49-F238E27FC236}">
-                <a16:creationId xmlns:a16="http://schemas.microsoft.com/office/drawing/2014/main" id="{AC701059-1651-4803-9C35-986C4D0DFB84}"/>
-              </a:ext>
-            </a:extLst>
-          </p:cNvPr>
-          <p:cNvSpPr>
-            <a:spLocks noGrp="1"/>
-          </p:cNvSpPr>
-          <p:nvPr/>
-        </p:nvSpPr>
-        <p:spPr>
-          <a:xfrm>
-            <a:off x="457200" y="657225"/>
-            <a:ext cx="11277600" cy="381000"/>
-          </a:xfrm>
-          <a:prstGeom prst="rect">
-            <a:avLst/>
-          </a:prstGeom>
-          <a:noFill/>
-          <a:ln w="0">
-            <a:noFill/>
-          </a:ln>
-        </p:spPr>
-        <p:txBody>
-          <a:bodyPr wrap="square" lIns="0" tIns="0" rIns="0" bIns="0" anchor="t">
-            <a:noAutofit/>
-          </a:bodyPr>
-          <a:lstStyle/>
-          <a:p>
-            <a:pPr algn="l">
-              <a:defRPr sz="2400" b="1">
-                <a:solidFill>
-                  <a:srgbClr val="333333"/>
-                </a:solidFill>
-                <a:latin typeface="Helvetica Neue"/>
-                <a:ea typeface="Helvetica Neue"/>
-                <a:cs typeface="Helvetica Neue"/>
-              </a:defRPr>
-            </a:pPr>
-            <a:r>
-              <a:rPr sz="2400" b="1">
-                <a:solidFill>
-                  <a:srgbClr val="333333"/>
-                </a:solidFill>
-                <a:latin typeface="Helvetica Neue"/>
-                <a:ea typeface="Helvetica Neue"/>
-                <a:cs typeface="Helvetica Neue"/>
-              </a:rPr>
-              <a:t>Цифровое самообслуживание</a:t>
-            </a:r>
-          </a:p>
-        </p:txBody>
-      </p:sp>
-      <p:sp>
-        <p:nvSpPr>
-          <p:cNvPr id="4" name="footer-rule">
-            <a:extLst>
-              <a:ext uri="{FF2B5EF4-FFF2-40B4-BE49-F238E27FC236}">
-                <a16:creationId xmlns:a16="http://schemas.microsoft.com/office/drawing/2014/main" id="{1877B535-BB3C-45FB-9440-4C6A72625F74}"/>
-              </a:ext>
-            </a:extLst>
-          </p:cNvPr>
-          <p:cNvSpPr>
-            <a:spLocks noGrp="1"/>
-          </p:cNvSpPr>
-          <p:nvPr/>
-        </p:nvSpPr>
-        <p:spPr>
-          <a:xfrm>
-            <a:off x="457200" y="6467475"/>
-            <a:ext cx="11277600" cy="0"/>
-          </a:xfrm>
-          <a:prstGeom prst="line">
-            <a:avLst/>
-          </a:prstGeom>
-          <a:noFill/>
-          <a:ln w="9525">
-            <a:solidFill>
-              <a:srgbClr val="EDEDED"/>
-            </a:solidFill>
-            <a:prstDash val="solid"/>
-          </a:ln>
-        </p:spPr>
-        <p:txBody>
-          <a:bodyPr/>
-          <a:lstStyle/>
-          <a:p>
-            <a:endParaRPr lang="en-JP"/>
-          </a:p>
-        </p:txBody>
-      </p:sp>
-      <p:sp>
-        <p:nvSpPr>
-          <p:cNvPr id="5" name="footer-reference">
-            <a:hlinkClick r:id="rId3" action="ppaction://hlinksldjump"/>
-            <a:extLst>
-              <a:ext uri="{FF2B5EF4-FFF2-40B4-BE49-F238E27FC236}">
-                <a16:creationId xmlns:a16="http://schemas.microsoft.com/office/drawing/2014/main" id="{1677C1CE-7A4E-4769-8303-F0EA781FC62D}"/>
-              </a:ext>
-            </a:extLst>
-          </p:cNvPr>
-          <p:cNvSpPr>
-            <a:spLocks noGrp="1"/>
-          </p:cNvSpPr>
-          <p:nvPr/>
-        </p:nvSpPr>
-        <p:spPr>
-          <a:xfrm>
-            <a:off x="457200" y="6591300"/>
-            <a:ext cx="10001250" cy="180975"/>
-          </a:xfrm>
-          <a:prstGeom prst="rect">
-            <a:avLst/>
-          </a:prstGeom>
-          <a:noFill/>
-          <a:ln w="0">
-            <a:noFill/>
-          </a:ln>
-        </p:spPr>
-        <p:txBody>
-          <a:bodyPr wrap="square" lIns="0" tIns="0" rIns="0" bIns="0" anchor="t">
-            <a:noAutofit/>
-          </a:bodyPr>
-          <a:lstStyle/>
-          <a:p>
-            <a:pPr algn="l">
-              <a:defRPr sz="900" b="0">
-                <a:solidFill>
-                  <a:srgbClr val="731982"/>
-                </a:solidFill>
-                <a:latin typeface="Helvetica Neue"/>
-                <a:ea typeface="Helvetica Neue"/>
-                <a:cs typeface="Helvetica Neue"/>
-              </a:defRPr>
-            </a:pPr>
-            <a:r>
-              <a:rPr sz="900" b="0" u="sng">
-                <a:solidFill>
-                  <a:srgbClr val="731982"/>
-                </a:solidFill>
-                <a:latin typeface="Helvetica Neue"/>
-                <a:ea typeface="Helvetica Neue"/>
-                <a:cs typeface="Helvetica Neue"/>
-              </a:rPr>
-              <a:t>Вернуться к шаблону · стр. 02</a:t>
-            </a:r>
-          </a:p>
-        </p:txBody>
-      </p:sp>
-      <p:sp>
-        <p:nvSpPr>
-          <p:cNvPr id="6" name="page">
-            <a:extLst>
-              <a:ext uri="{FF2B5EF4-FFF2-40B4-BE49-F238E27FC236}">
-                <a16:creationId xmlns:a16="http://schemas.microsoft.com/office/drawing/2014/main" id="{00D4170D-3CE9-455B-8517-7BD72A17E1EA}"/>
-              </a:ext>
-            </a:extLst>
-          </p:cNvPr>
-          <p:cNvSpPr>
-            <a:spLocks noGrp="1"/>
-          </p:cNvSpPr>
-          <p:nvPr/>
-        </p:nvSpPr>
-        <p:spPr>
-          <a:xfrm>
-            <a:off x="10725150" y="6591300"/>
-            <a:ext cx="1009650" cy="180975"/>
-          </a:xfrm>
-          <a:prstGeom prst="rect">
-            <a:avLst/>
-          </a:prstGeom>
-          <a:noFill/>
-          <a:ln w="0">
-            <a:noFill/>
-          </a:ln>
-        </p:spPr>
-        <p:txBody>
-          <a:bodyPr wrap="square" lIns="0" tIns="0" rIns="0" bIns="0" anchor="t">
-            <a:noAutofit/>
-          </a:bodyPr>
-          <a:lstStyle/>
-          <a:p>
-            <a:pPr algn="r">
-              <a:defRPr sz="900" b="0">
-                <a:solidFill>
-                  <a:srgbClr val="5F5F5F"/>
-                </a:solidFill>
-                <a:latin typeface="Helvetica Neue"/>
-                <a:ea typeface="Helvetica Neue"/>
-                <a:cs typeface="Helvetica Neue"/>
-              </a:defRPr>
-            </a:pPr>
-            <a:r>
-              <a:rPr sz="900" b="0">
-                <a:solidFill>
-                  <a:srgbClr val="5F5F5F"/>
-                </a:solidFill>
-                <a:latin typeface="Helvetica Neue"/>
-                <a:ea typeface="Helvetica Neue"/>
-                <a:cs typeface="Helvetica Neue"/>
-              </a:rPr>
-              <a:t>08 / 14</a:t>
-            </a:r>
-          </a:p>
-        </p:txBody>
-      </p:sp>
-      <p:sp>
-        <p:nvSpPr>
-          <p:cNvPr id="7" name="intro">
-            <a:extLst>
-              <a:ext uri="{FF2B5EF4-FFF2-40B4-BE49-F238E27FC236}">
-                <a16:creationId xmlns:a16="http://schemas.microsoft.com/office/drawing/2014/main" id="{F3692B4D-D3F1-4719-89E0-34936DBE1DD5}"/>
-              </a:ext>
-            </a:extLst>
-          </p:cNvPr>
-          <p:cNvSpPr>
-            <a:spLocks noGrp="1"/>
-          </p:cNvSpPr>
-          <p:nvPr/>
-        </p:nvSpPr>
-        <p:spPr>
-          <a:xfrm>
-            <a:off x="457200" y="1200150"/>
-            <a:ext cx="11277600" cy="495300"/>
-          </a:xfrm>
-          <a:prstGeom prst="rect">
-            <a:avLst/>
-          </a:prstGeom>
-          <a:noFill/>
-          <a:ln w="0">
-            <a:noFill/>
-          </a:ln>
-        </p:spPr>
-        <p:txBody>
-          <a:bodyPr wrap="square" lIns="0" tIns="0" rIns="0" bIns="0" anchor="t">
-            <a:noAutofit/>
-          </a:bodyPr>
-          <a:lstStyle/>
-          <a:p>
-            <a:pPr algn="l">
-              <a:defRPr sz="1275" b="0">
-                <a:solidFill>
-                  <a:srgbClr val="5F5F5F"/>
-                </a:solidFill>
-                <a:latin typeface="Helvetica Neue"/>
-                <a:ea typeface="Helvetica Neue"/>
-                <a:cs typeface="Helvetica Neue"/>
-              </a:defRPr>
-            </a:pPr>
-            <a:r>
-              <a:rPr sz="1275" b="0">
-                <a:solidFill>
-                  <a:srgbClr val="5F5F5F"/>
-                </a:solidFill>
-                <a:latin typeface="Helvetica Neue"/>
-                <a:ea typeface="Helvetica Neue"/>
-                <a:cs typeface="Helvetica Neue"/>
-              </a:rPr>
-              <a:t>Помогаем клиентам самостоятельно оплачивать связь, управлять тарифом и подключать сервисы в личном кабинете.</a:t>
-            </a:r>
-          </a:p>
-        </p:txBody>
-      </p:sp>
-      <p:sp>
-        <p:nvSpPr>
-          <p:cNvPr id="8" name="products-label">
-            <a:extLst>
-              <a:ext uri="{FF2B5EF4-FFF2-40B4-BE49-F238E27FC236}">
-                <a16:creationId xmlns:a16="http://schemas.microsoft.com/office/drawing/2014/main" id="{AE7E5CDB-5515-491E-81A2-2F638B6043C0}"/>
-              </a:ext>
-            </a:extLst>
-          </p:cNvPr>
-          <p:cNvSpPr>
-            <a:spLocks noGrp="1"/>
-          </p:cNvSpPr>
-          <p:nvPr/>
-        </p:nvSpPr>
-        <p:spPr>
-          <a:xfrm>
-            <a:off x="457200" y="1762125"/>
-            <a:ext cx="11277600" cy="285750"/>
-          </a:xfrm>
-          <a:prstGeom prst="rect">
-            <a:avLst/>
-          </a:prstGeom>
-          <a:noFill/>
-          <a:ln w="0">
-            <a:noFill/>
-          </a:ln>
-        </p:spPr>
-        <p:txBody>
-          <a:bodyPr wrap="square" lIns="0" tIns="0" rIns="0" bIns="0" anchor="t">
-            <a:noAutofit/>
-          </a:bodyPr>
-          <a:lstStyle/>
-          <a:p>
-            <a:pPr algn="l">
-              <a:defRPr sz="1500" b="1">
-                <a:solidFill>
-                  <a:srgbClr val="333333"/>
-                </a:solidFill>
-                <a:latin typeface="Helvetica Neue"/>
-                <a:ea typeface="Helvetica Neue"/>
-                <a:cs typeface="Helvetica Neue"/>
-              </a:defRPr>
-            </a:pPr>
-            <a:r>
-              <a:rPr sz="1500" b="1">
-                <a:solidFill>
-                  <a:srgbClr val="333333"/>
-                </a:solidFill>
-                <a:latin typeface="Helvetica Neue"/>
-                <a:ea typeface="Helvetica Neue"/>
-                <a:cs typeface="Helvetica Neue"/>
-              </a:rPr>
-              <a:t>Продукты внутри направления</a:t>
-            </a:r>
-          </a:p>
-        </p:txBody>
-      </p:sp>
-      <p:sp>
-        <p:nvSpPr>
-          <p:cNvPr id="9" name="product-surface-0">
-            <a:extLst>
-              <a:ext uri="{FF2B5EF4-FFF2-40B4-BE49-F238E27FC236}">
-                <a16:creationId xmlns:a16="http://schemas.microsoft.com/office/drawing/2014/main" id="{E91C77F1-FCBF-4DC1-B2B6-F87BC7B54597}"/>
-              </a:ext>
-            </a:extLst>
-          </p:cNvPr>
-          <p:cNvSpPr>
-            <a:spLocks noGrp="1"/>
-          </p:cNvSpPr>
-          <p:nvPr/>
-        </p:nvSpPr>
-        <p:spPr>
-          <a:xfrm>
-            <a:off x="457200" y="2143125"/>
-            <a:ext cx="1866900" cy="419100"/>
-          </a:xfrm>
-          <a:prstGeom prst="roundRect">
-            <a:avLst>
-              <a:gd name="adj" fmla="val 18182"/>
-            </a:avLst>
-          </a:prstGeom>
-          <a:solidFill>
-            <a:srgbClr val="F6F6F6"/>
-          </a:solidFill>
-          <a:ln w="0">
-            <a:noFill/>
-          </a:ln>
-        </p:spPr>
-        <p:txBody>
-          <a:bodyPr/>
-          <a:lstStyle/>
-          <a:p>
-            <a:endParaRPr lang="en-JP"/>
-          </a:p>
-        </p:txBody>
-      </p:sp>
-      <p:sp>
-        <p:nvSpPr>
-          <p:cNvPr id="10" name="product-0">
-            <a:extLst>
-              <a:ext uri="{FF2B5EF4-FFF2-40B4-BE49-F238E27FC236}">
-                <a16:creationId xmlns:a16="http://schemas.microsoft.com/office/drawing/2014/main" id="{C6B01A13-E514-4745-BBE8-AEB29449BD48}"/>
-              </a:ext>
-            </a:extLst>
-          </p:cNvPr>
-          <p:cNvSpPr>
-            <a:spLocks noGrp="1"/>
-          </p:cNvSpPr>
-          <p:nvPr/>
-        </p:nvSpPr>
-        <p:spPr>
-          <a:xfrm>
-            <a:off x="600075" y="2238375"/>
-            <a:ext cx="1581150" cy="238125"/>
-          </a:xfrm>
-          <a:prstGeom prst="rect">
-            <a:avLst/>
-          </a:prstGeom>
-          <a:noFill/>
-          <a:ln w="0">
-            <a:noFill/>
-          </a:ln>
-        </p:spPr>
-        <p:txBody>
-          <a:bodyPr wrap="square" lIns="0" tIns="0" rIns="0" bIns="0" anchor="t">
-            <a:noAutofit/>
-          </a:bodyPr>
-          <a:lstStyle/>
-          <a:p>
-            <a:pPr algn="l">
-              <a:defRPr sz="1200" b="0">
-                <a:solidFill>
-                  <a:srgbClr val="333333"/>
-                </a:solidFill>
-                <a:latin typeface="Helvetica Neue"/>
-                <a:ea typeface="Helvetica Neue"/>
-                <a:cs typeface="Helvetica Neue"/>
-              </a:defRPr>
-            </a:pPr>
-            <a:r>
-              <a:rPr sz="1200" b="0">
-                <a:solidFill>
-                  <a:srgbClr val="333333"/>
-                </a:solidFill>
-                <a:latin typeface="Helvetica Neue"/>
-                <a:ea typeface="Helvetica Neue"/>
-                <a:cs typeface="Helvetica Neue"/>
-              </a:rPr>
-              <a:t>Оплата и пополнение</a:t>
-            </a:r>
-          </a:p>
-        </p:txBody>
-      </p:sp>
-      <p:sp>
-        <p:nvSpPr>
-          <p:cNvPr id="11" name="product-surface-1">
-            <a:extLst>
-              <a:ext uri="{FF2B5EF4-FFF2-40B4-BE49-F238E27FC236}">
-                <a16:creationId xmlns:a16="http://schemas.microsoft.com/office/drawing/2014/main" id="{9A30CBB3-B774-486B-9672-FE137D886F58}"/>
-              </a:ext>
-            </a:extLst>
-          </p:cNvPr>
-          <p:cNvSpPr>
-            <a:spLocks noGrp="1"/>
-          </p:cNvSpPr>
-          <p:nvPr/>
-        </p:nvSpPr>
-        <p:spPr>
-          <a:xfrm>
-            <a:off x="2438400" y="2143125"/>
-            <a:ext cx="2657475" cy="419100"/>
-          </a:xfrm>
-          <a:prstGeom prst="roundRect">
-            <a:avLst>
-              <a:gd name="adj" fmla="val 18182"/>
-            </a:avLst>
-          </a:prstGeom>
-          <a:solidFill>
-            <a:srgbClr val="F6F6F6"/>
-          </a:solidFill>
-          <a:ln w="0">
-            <a:noFill/>
-          </a:ln>
-        </p:spPr>
-        <p:txBody>
-          <a:bodyPr/>
-          <a:lstStyle/>
-          <a:p>
-            <a:endParaRPr lang="en-JP"/>
-          </a:p>
-        </p:txBody>
-      </p:sp>
-      <p:sp>
-        <p:nvSpPr>
-          <p:cNvPr id="12" name="product-1">
-            <a:extLst>
-              <a:ext uri="{FF2B5EF4-FFF2-40B4-BE49-F238E27FC236}">
-                <a16:creationId xmlns:a16="http://schemas.microsoft.com/office/drawing/2014/main" id="{071849F6-62E5-4D2C-9C8C-8C5E8C5740FC}"/>
-              </a:ext>
-            </a:extLst>
-          </p:cNvPr>
-          <p:cNvSpPr>
-            <a:spLocks noGrp="1"/>
-          </p:cNvSpPr>
-          <p:nvPr/>
-        </p:nvSpPr>
-        <p:spPr>
-          <a:xfrm>
-            <a:off x="2581275" y="2238375"/>
-            <a:ext cx="2371725" cy="238125"/>
-          </a:xfrm>
-          <a:prstGeom prst="rect">
-            <a:avLst/>
-          </a:prstGeom>
-          <a:noFill/>
-          <a:ln w="0">
-            <a:noFill/>
-          </a:ln>
-        </p:spPr>
-        <p:txBody>
-          <a:bodyPr wrap="square" lIns="0" tIns="0" rIns="0" bIns="0" anchor="t">
-            <a:noAutofit/>
-          </a:bodyPr>
-          <a:lstStyle/>
-          <a:p>
-            <a:pPr algn="l">
-              <a:defRPr sz="1200" b="0">
-                <a:solidFill>
-                  <a:srgbClr val="333333"/>
-                </a:solidFill>
-                <a:latin typeface="Helvetica Neue"/>
-                <a:ea typeface="Helvetica Neue"/>
-                <a:cs typeface="Helvetica Neue"/>
-              </a:defRPr>
-            </a:pPr>
-            <a:r>
-              <a:rPr sz="1200" b="0">
-                <a:solidFill>
-                  <a:srgbClr val="333333"/>
-                </a:solidFill>
-                <a:latin typeface="Helvetica Neue"/>
-                <a:ea typeface="Helvetica Neue"/>
-                <a:cs typeface="Helvetica Neue"/>
-              </a:rPr>
-              <a:t>Управление тарифом и опциями</a:t>
-            </a:r>
-          </a:p>
-        </p:txBody>
-      </p:sp>
-      <p:sp>
-        <p:nvSpPr>
-          <p:cNvPr id="13" name="product-surface-2">
-            <a:extLst>
-              <a:ext uri="{FF2B5EF4-FFF2-40B4-BE49-F238E27FC236}">
-                <a16:creationId xmlns:a16="http://schemas.microsoft.com/office/drawing/2014/main" id="{DE0B5566-EC4A-4C83-8946-ABB2FE5D914A}"/>
-              </a:ext>
-            </a:extLst>
-          </p:cNvPr>
-          <p:cNvSpPr>
-            <a:spLocks noGrp="1"/>
-          </p:cNvSpPr>
-          <p:nvPr/>
-        </p:nvSpPr>
-        <p:spPr>
-          <a:xfrm>
-            <a:off x="5210175" y="2143125"/>
-            <a:ext cx="2647950" cy="419100"/>
-          </a:xfrm>
-          <a:prstGeom prst="roundRect">
-            <a:avLst>
-              <a:gd name="adj" fmla="val 18182"/>
-            </a:avLst>
-          </a:prstGeom>
-          <a:solidFill>
-            <a:srgbClr val="F6F6F6"/>
-          </a:solidFill>
-          <a:ln w="0">
-            <a:noFill/>
-          </a:ln>
-        </p:spPr>
-        <p:txBody>
-          <a:bodyPr/>
-          <a:lstStyle/>
-          <a:p>
-            <a:endParaRPr lang="en-JP"/>
-          </a:p>
-        </p:txBody>
-      </p:sp>
-      <p:sp>
-        <p:nvSpPr>
-          <p:cNvPr id="14" name="product-2">
-            <a:extLst>
-              <a:ext uri="{FF2B5EF4-FFF2-40B4-BE49-F238E27FC236}">
-                <a16:creationId xmlns:a16="http://schemas.microsoft.com/office/drawing/2014/main" id="{1A978EEE-9D3C-4981-9745-5EDD11946643}"/>
-              </a:ext>
-            </a:extLst>
-          </p:cNvPr>
-          <p:cNvSpPr>
-            <a:spLocks noGrp="1"/>
-          </p:cNvSpPr>
-          <p:nvPr/>
-        </p:nvSpPr>
-        <p:spPr>
-          <a:xfrm>
-            <a:off x="5353050" y="2238375"/>
-            <a:ext cx="2362200" cy="238125"/>
-          </a:xfrm>
-          <a:prstGeom prst="rect">
-            <a:avLst/>
-          </a:prstGeom>
-          <a:noFill/>
-          <a:ln w="0">
-            <a:noFill/>
-          </a:ln>
-        </p:spPr>
-        <p:txBody>
-          <a:bodyPr wrap="square" lIns="0" tIns="0" rIns="0" bIns="0" anchor="t">
-            <a:noAutofit/>
-          </a:bodyPr>
-          <a:lstStyle/>
-          <a:p>
-            <a:pPr algn="l">
-              <a:defRPr sz="1200" b="0">
-                <a:solidFill>
-                  <a:srgbClr val="333333"/>
-                </a:solidFill>
-                <a:latin typeface="Helvetica Neue"/>
-                <a:ea typeface="Helvetica Neue"/>
-                <a:cs typeface="Helvetica Neue"/>
-              </a:defRPr>
-            </a:pPr>
-            <a:r>
-              <a:rPr sz="1200" b="0">
-                <a:solidFill>
-                  <a:srgbClr val="333333"/>
-                </a:solidFill>
-                <a:latin typeface="Helvetica Neue"/>
-                <a:ea typeface="Helvetica Neue"/>
-                <a:cs typeface="Helvetica Neue"/>
-              </a:rPr>
-              <a:t>Подписки и семейные продукты</a:t>
-            </a:r>
-          </a:p>
-        </p:txBody>
-      </p:sp>
-      <p:sp>
-        <p:nvSpPr>
-          <p:cNvPr id="15" name="goals-label">
-            <a:extLst>
-              <a:ext uri="{FF2B5EF4-FFF2-40B4-BE49-F238E27FC236}">
-                <a16:creationId xmlns:a16="http://schemas.microsoft.com/office/drawing/2014/main" id="{E83C4AC7-82D7-4E6B-BD4D-2039DA477AB7}"/>
-              </a:ext>
-            </a:extLst>
-          </p:cNvPr>
-          <p:cNvSpPr>
-            <a:spLocks noGrp="1"/>
-          </p:cNvSpPr>
-          <p:nvPr/>
-        </p:nvSpPr>
-        <p:spPr>
-          <a:xfrm>
-            <a:off x="457200" y="2971800"/>
-            <a:ext cx="11277600" cy="285750"/>
-          </a:xfrm>
-          <a:prstGeom prst="rect">
-            <a:avLst/>
-          </a:prstGeom>
-          <a:noFill/>
-          <a:ln w="0">
-            <a:noFill/>
-          </a:ln>
-        </p:spPr>
-        <p:txBody>
-          <a:bodyPr wrap="square" lIns="0" tIns="0" rIns="0" bIns="0" anchor="t">
-            <a:noAutofit/>
-          </a:bodyPr>
-          <a:lstStyle/>
-          <a:p>
-            <a:pPr algn="l">
-              <a:defRPr sz="1500" b="1">
-                <a:solidFill>
-                  <a:srgbClr val="333333"/>
-                </a:solidFill>
-                <a:latin typeface="Helvetica Neue"/>
-                <a:ea typeface="Helvetica Neue"/>
-                <a:cs typeface="Helvetica Neue"/>
-              </a:defRPr>
-            </a:pPr>
-            <a:r>
-              <a:rPr sz="1500" b="1">
-                <a:solidFill>
-                  <a:srgbClr val="333333"/>
-                </a:solidFill>
-                <a:latin typeface="Helvetica Neue"/>
-                <a:ea typeface="Helvetica Neue"/>
-                <a:cs typeface="Helvetica Neue"/>
-              </a:rPr>
-              <a:t>Цели направления</a:t>
-            </a:r>
-          </a:p>
-        </p:txBody>
-      </p:sp>
-      <p:graphicFrame>
-        <p:nvGraphicFramePr>
-          <p:cNvPr id="33" name="Table 32"/>
-          <p:cNvGraphicFramePr/>
-          <p:nvPr>
-            <p:extLst>
-              <p:ext uri="{D42A27DB-BD31-4B8C-83A1-F6EECF244321}">
-                <p14:modId xmlns:p14="http://schemas.microsoft.com/office/powerpoint/2010/main" val="237564533"/>
-              </p:ext>
-            </p:extLst>
-          </p:nvPr>
-        </p:nvGraphicFramePr>
-        <p:xfrm>
-          <a:off x="457200" y="3371850"/>
-          <a:ext cx="10001250" cy="1819275"/>
-        </p:xfrm>
-        <a:graphic>
-          <a:graphicData uri="http://schemas.openxmlformats.org/drawingml/2006/table">
-            <a:tbl>
-              <a:tblPr/>
-              <a:tblGrid>
-                <a:gridCol w="4600575">
-                  <a:extLst>
-                    <a:ext uri="{9D8B030D-6E8A-4147-A177-3AD203B41FA5}">
-                      <a16:colId xmlns:a16="http://schemas.microsoft.com/office/drawing/2014/main" val="20000"/>
-                    </a:ext>
-                  </a:extLst>
-                </a:gridCol>
-                <a:gridCol w="5400675">
-                  <a:extLst>
-                    <a:ext uri="{9D8B030D-6E8A-4147-A177-3AD203B41FA5}">
-                      <a16:colId xmlns:a16="http://schemas.microsoft.com/office/drawing/2014/main" val="20001"/>
-                    </a:ext>
-                  </a:extLst>
-                </a:gridCol>
-              </a:tblGrid>
-              <a:tr h="447675">
-                <a:tc>
-                  <a:txBody>
-                    <a:bodyPr/>
-                    <a:lstStyle/>
-                    <a:p>
-                      <a:pPr algn="l">
-                        <a:lnSpc>
-                          <a:spcPts val="1365"/>
-                        </a:lnSpc>
-                        <a:spcBef>
-                          <a:spcPts val="0"/>
-                        </a:spcBef>
-                        <a:spcAft>
-                          <a:spcPts val="0"/>
-                        </a:spcAft>
-                      </a:pPr>
-                      <a:r>
-                        <a:rPr sz="1100" b="1">
-                          <a:solidFill>
-                            <a:srgbClr val="333333"/>
-                          </a:solidFill>
-                          <a:latin typeface="Helvetica Neue"/>
-                          <a:ea typeface="Helvetica Neue"/>
-                          <a:cs typeface="Helvetica Neue"/>
-                        </a:rPr>
-                        <a:t>Какой результат хотим получить</a:t>
-                      </a:r>
-                    </a:p>
-                  </a:txBody>
-                  <a:tcPr marL="114300" marR="114300" marT="123825" marB="123825">
-                    <a:lnL w="0">
-                      <a:noFill/>
-                    </a:lnL>
-                    <a:lnR w="0">
-                      <a:noFill/>
-                    </a:lnR>
-                    <a:lnT w="0">
-                      <a:noFill/>
-                    </a:lnT>
-                    <a:lnB w="9525">
-                      <a:solidFill>
-                        <a:srgbClr val="EDEDED"/>
-                      </a:solidFill>
-                    </a:lnB>
-                    <a:solidFill>
-                      <a:srgbClr val="F6F6F6"/>
-                    </a:solidFill>
-                  </a:tcPr>
-                </a:tc>
-                <a:tc>
-                  <a:txBody>
-                    <a:bodyPr/>
-                    <a:lstStyle/>
-                    <a:p>
-                      <a:pPr algn="l">
-                        <a:lnSpc>
-                          <a:spcPts val="1365"/>
-                        </a:lnSpc>
-                        <a:spcBef>
-                          <a:spcPts val="0"/>
-                        </a:spcBef>
-                        <a:spcAft>
-                          <a:spcPts val="0"/>
-                        </a:spcAft>
-                      </a:pPr>
-                      <a:r>
-                        <a:rPr sz="1100" b="1" dirty="0" err="1">
-                          <a:solidFill>
-                            <a:srgbClr val="333333"/>
-                          </a:solidFill>
-                          <a:latin typeface="Helvetica Neue"/>
-                          <a:ea typeface="Helvetica Neue"/>
-                          <a:cs typeface="Helvetica Neue"/>
-                        </a:rPr>
-                        <a:t>Как</a:t>
-                      </a:r>
-                      <a:r>
-                        <a:rPr sz="1100" b="1" dirty="0">
-                          <a:solidFill>
-                            <a:srgbClr val="333333"/>
-                          </a:solidFill>
-                          <a:latin typeface="Helvetica Neue"/>
-                          <a:ea typeface="Helvetica Neue"/>
-                          <a:cs typeface="Helvetica Neue"/>
-                        </a:rPr>
-                        <a:t> </a:t>
-                      </a:r>
-                      <a:r>
-                        <a:rPr sz="1100" b="1" dirty="0" err="1">
-                          <a:solidFill>
-                            <a:srgbClr val="333333"/>
-                          </a:solidFill>
-                          <a:latin typeface="Helvetica Neue"/>
-                          <a:ea typeface="Helvetica Neue"/>
-                          <a:cs typeface="Helvetica Neue"/>
-                        </a:rPr>
-                        <a:t>поймём</a:t>
-                      </a:r>
-                      <a:r>
-                        <a:rPr sz="1100" b="1" dirty="0">
-                          <a:solidFill>
-                            <a:srgbClr val="333333"/>
-                          </a:solidFill>
-                          <a:latin typeface="Helvetica Neue"/>
-                          <a:ea typeface="Helvetica Neue"/>
-                          <a:cs typeface="Helvetica Neue"/>
-                        </a:rPr>
-                        <a:t>, </a:t>
-                      </a:r>
-                      <a:r>
-                        <a:rPr sz="1100" b="1" dirty="0" err="1">
-                          <a:solidFill>
-                            <a:srgbClr val="333333"/>
-                          </a:solidFill>
-                          <a:latin typeface="Helvetica Neue"/>
-                          <a:ea typeface="Helvetica Neue"/>
-                          <a:cs typeface="Helvetica Neue"/>
-                        </a:rPr>
-                        <a:t>что</a:t>
-                      </a:r>
-                      <a:r>
-                        <a:rPr sz="1100" b="1" dirty="0">
-                          <a:solidFill>
-                            <a:srgbClr val="333333"/>
-                          </a:solidFill>
-                          <a:latin typeface="Helvetica Neue"/>
-                          <a:ea typeface="Helvetica Neue"/>
-                          <a:cs typeface="Helvetica Neue"/>
-                        </a:rPr>
-                        <a:t> </a:t>
-                      </a:r>
-                      <a:r>
-                        <a:rPr sz="1100" b="1" dirty="0" err="1">
-                          <a:solidFill>
-                            <a:srgbClr val="333333"/>
-                          </a:solidFill>
-                          <a:latin typeface="Helvetica Neue"/>
-                          <a:ea typeface="Helvetica Neue"/>
-                          <a:cs typeface="Helvetica Neue"/>
-                        </a:rPr>
-                        <a:t>достигли</a:t>
-                      </a:r>
-                      <a:r>
-                        <a:rPr sz="1100" b="1" dirty="0">
-                          <a:solidFill>
-                            <a:srgbClr val="333333"/>
-                          </a:solidFill>
-                          <a:latin typeface="Helvetica Neue"/>
-                          <a:ea typeface="Helvetica Neue"/>
-                          <a:cs typeface="Helvetica Neue"/>
-                        </a:rPr>
-                        <a:t> </a:t>
-                      </a:r>
-                      <a:r>
-                        <a:rPr sz="1100" b="1" dirty="0" err="1">
-                          <a:solidFill>
-                            <a:srgbClr val="333333"/>
-                          </a:solidFill>
-                          <a:latin typeface="Helvetica Neue"/>
-                          <a:ea typeface="Helvetica Neue"/>
-                          <a:cs typeface="Helvetica Neue"/>
-                        </a:rPr>
-                        <a:t>цели</a:t>
-                      </a:r>
-                      <a:endParaRPr sz="1100" b="1" dirty="0">
-                        <a:solidFill>
-                          <a:srgbClr val="333333"/>
-                        </a:solidFill>
-                        <a:latin typeface="Helvetica Neue"/>
-                        <a:ea typeface="Helvetica Neue"/>
-                        <a:cs typeface="Helvetica Neue"/>
-                      </a:endParaRPr>
-                    </a:p>
-                  </a:txBody>
-                  <a:tcPr marL="114300" marR="114300" marT="123825" marB="123825">
-                    <a:lnL w="0">
-                      <a:noFill/>
-                    </a:lnL>
-                    <a:lnR w="0">
-                      <a:noFill/>
-                    </a:lnR>
-                    <a:lnT w="0">
-                      <a:noFill/>
-                    </a:lnT>
-                    <a:lnB w="9525">
-                      <a:solidFill>
-                        <a:srgbClr val="EDEDED"/>
-                      </a:solidFill>
-                    </a:lnB>
-                    <a:solidFill>
-                      <a:srgbClr val="F6F6F6"/>
-                    </a:solidFill>
-                  </a:tcPr>
-                </a:tc>
-                <a:extLst>
-                  <a:ext uri="{0D108BD9-81ED-4DB2-BD59-A6C34878D82A}">
-                    <a16:rowId xmlns:a16="http://schemas.microsoft.com/office/drawing/2014/main" val="10000"/>
-                  </a:ext>
-                </a:extLst>
-              </a:tr>
-              <a:tr h="685800">
-                <a:tc>
-                  <a:txBody>
-                    <a:bodyPr/>
-                    <a:lstStyle/>
-                    <a:p>
-                      <a:pPr algn="l">
-                        <a:lnSpc>
-                          <a:spcPts val="1575"/>
-                        </a:lnSpc>
-                        <a:spcBef>
-                          <a:spcPts val="0"/>
-                        </a:spcBef>
-                        <a:spcAft>
-                          <a:spcPts val="0"/>
-                        </a:spcAft>
-                      </a:pPr>
-                      <a:r>
-                        <a:rPr sz="1125" b="0">
-                          <a:solidFill>
-                            <a:srgbClr val="333333"/>
-                          </a:solidFill>
-                          <a:latin typeface="Helvetica Neue"/>
-                          <a:ea typeface="Helvetica Neue"/>
-                          <a:cs typeface="Helvetica Neue"/>
-                        </a:rPr>
-                        <a:t>Клиенты успешно завершают оплату в ЛК.</a:t>
-                      </a:r>
-                    </a:p>
-                  </a:txBody>
-                  <a:tcPr marL="114300" marR="114300" marT="123825" marB="123825">
-                    <a:lnL w="0">
-                      <a:noFill/>
-                    </a:lnL>
-                    <a:lnR w="0">
-                      <a:noFill/>
-                    </a:lnR>
-                    <a:lnT w="9525" cap="flat" cmpd="sng" algn="ctr">
-                      <a:solidFill>
-                        <a:srgbClr val="EDEDED"/>
-                      </a:solidFill>
-                      <a:prstDash val="solid"/>
-                      <a:round/>
-                      <a:headEnd type="none" w="med" len="med"/>
-                      <a:tailEnd type="none" w="med" len="med"/>
-                    </a:lnT>
-                    <a:lnB w="9525">
-                      <a:solidFill>
-                        <a:srgbClr val="EDEDED"/>
-                      </a:solidFill>
-                    </a:lnB>
-                    <a:solidFill>
-                      <a:srgbClr val="FFFFFF"/>
-                    </a:solidFill>
-                  </a:tcPr>
-                </a:tc>
-                <a:tc>
-                  <a:txBody>
-                    <a:bodyPr/>
-                    <a:lstStyle/>
-                    <a:p>
-                      <a:pPr algn="l">
-                        <a:lnSpc>
-                          <a:spcPts val="1575"/>
-                        </a:lnSpc>
-                        <a:spcBef>
-                          <a:spcPts val="0"/>
-                        </a:spcBef>
-                        <a:spcAft>
-                          <a:spcPts val="0"/>
-                        </a:spcAft>
-                      </a:pPr>
-                      <a:r>
-                        <a:rPr sz="1125" b="0">
-                          <a:solidFill>
-                            <a:srgbClr val="5F5F5F"/>
-                          </a:solidFill>
-                          <a:latin typeface="Helvetica Neue"/>
-                          <a:ea typeface="Helvetica Neue"/>
-                          <a:cs typeface="Helvetica Neue"/>
-                        </a:rPr>
-                        <a:t>Доля успешных оплат — 73% попыток к 31.12.2026.</a:t>
-                      </a:r>
-                    </a:p>
-                  </a:txBody>
-                  <a:tcPr marL="114300" marR="114300" marT="123825" marB="123825">
-                    <a:lnL w="0">
-                      <a:noFill/>
-                    </a:lnL>
-                    <a:lnR w="0">
-                      <a:noFill/>
-                    </a:lnR>
-                    <a:lnT w="9525" cap="flat" cmpd="sng" algn="ctr">
-                      <a:solidFill>
-                        <a:srgbClr val="EDEDED"/>
-                      </a:solidFill>
-                      <a:prstDash val="solid"/>
-                      <a:round/>
-                      <a:headEnd type="none" w="med" len="med"/>
-                      <a:tailEnd type="none" w="med" len="med"/>
-                    </a:lnT>
-                    <a:lnB w="9525">
-                      <a:solidFill>
-                        <a:srgbClr val="EDEDED"/>
-                      </a:solidFill>
-                    </a:lnB>
-                    <a:solidFill>
-                      <a:srgbClr val="FFFFFF"/>
-                    </a:solidFill>
-                  </a:tcPr>
-                </a:tc>
-                <a:extLst>
-                  <a:ext uri="{0D108BD9-81ED-4DB2-BD59-A6C34878D82A}">
-                    <a16:rowId xmlns:a16="http://schemas.microsoft.com/office/drawing/2014/main" val="10001"/>
-                  </a:ext>
-                </a:extLst>
-              </a:tr>
-              <a:tr h="685800">
-                <a:tc>
-                  <a:txBody>
-                    <a:bodyPr/>
-                    <a:lstStyle/>
-                    <a:p>
-                      <a:pPr algn="l">
-                        <a:lnSpc>
-                          <a:spcPts val="1575"/>
-                        </a:lnSpc>
-                        <a:spcBef>
-                          <a:spcPts val="0"/>
-                        </a:spcBef>
-                        <a:spcAft>
-                          <a:spcPts val="0"/>
-                        </a:spcAft>
-                      </a:pPr>
-                      <a:r>
-                        <a:rPr sz="1125" b="0">
-                          <a:solidFill>
-                            <a:srgbClr val="333333"/>
-                          </a:solidFill>
-                          <a:latin typeface="Helvetica Neue"/>
-                          <a:ea typeface="Helvetica Neue"/>
-                          <a:cs typeface="Helvetica Neue"/>
-                        </a:rPr>
-                        <a:t>Клиентам понятен и удобен сценарий оплаты.</a:t>
-                      </a:r>
-                    </a:p>
-                  </a:txBody>
-                  <a:tcPr marL="114300" marR="114300" marT="123825" marB="123825">
-                    <a:lnL w="0">
-                      <a:noFill/>
-                    </a:lnL>
-                    <a:lnR w="0">
-                      <a:noFill/>
-                    </a:lnR>
-                    <a:lnT w="9525" cap="flat" cmpd="sng" algn="ctr">
-                      <a:solidFill>
-                        <a:srgbClr val="EDEDED"/>
-                      </a:solidFill>
-                      <a:prstDash val="solid"/>
-                      <a:round/>
-                      <a:headEnd type="none" w="med" len="med"/>
-                      <a:tailEnd type="none" w="med" len="med"/>
-                    </a:lnT>
-                    <a:lnB w="9525">
-                      <a:solidFill>
-                        <a:srgbClr val="EDEDED"/>
-                      </a:solidFill>
-                    </a:lnB>
-                    <a:solidFill>
-                      <a:srgbClr val="FFFFFF"/>
-                    </a:solidFill>
-                  </a:tcPr>
-                </a:tc>
-                <a:tc>
-                  <a:txBody>
-                    <a:bodyPr/>
-                    <a:lstStyle/>
-                    <a:p>
-                      <a:pPr algn="l">
-                        <a:lnSpc>
-                          <a:spcPts val="1575"/>
-                        </a:lnSpc>
-                        <a:spcBef>
-                          <a:spcPts val="0"/>
-                        </a:spcBef>
-                        <a:spcAft>
-                          <a:spcPts val="0"/>
-                        </a:spcAft>
-                      </a:pPr>
-                      <a:r>
-                        <a:rPr sz="1125" b="0" dirty="0">
-                          <a:solidFill>
-                            <a:srgbClr val="5F5F5F"/>
-                          </a:solidFill>
-                          <a:latin typeface="Helvetica Neue"/>
-                          <a:ea typeface="Helvetica Neue"/>
-                          <a:cs typeface="Helvetica Neue"/>
-                        </a:rPr>
-                        <a:t>CSI </a:t>
-                      </a:r>
-                      <a:r>
-                        <a:rPr sz="1125" b="0" dirty="0" err="1">
-                          <a:solidFill>
-                            <a:srgbClr val="5F5F5F"/>
-                          </a:solidFill>
-                          <a:latin typeface="Helvetica Neue"/>
-                          <a:ea typeface="Helvetica Neue"/>
-                          <a:cs typeface="Helvetica Neue"/>
-                        </a:rPr>
-                        <a:t>оплаты</a:t>
-                      </a:r>
-                      <a:r>
-                        <a:rPr sz="1125" b="0" dirty="0">
-                          <a:solidFill>
-                            <a:srgbClr val="5F5F5F"/>
-                          </a:solidFill>
-                          <a:latin typeface="Helvetica Neue"/>
-                          <a:ea typeface="Helvetica Neue"/>
-                          <a:cs typeface="Helvetica Neue"/>
-                        </a:rPr>
-                        <a:t> — 78 </a:t>
-                      </a:r>
-                      <a:r>
-                        <a:rPr sz="1125" b="0" dirty="0" err="1">
-                          <a:solidFill>
-                            <a:srgbClr val="5F5F5F"/>
-                          </a:solidFill>
-                          <a:latin typeface="Helvetica Neue"/>
-                          <a:ea typeface="Helvetica Neue"/>
-                          <a:cs typeface="Helvetica Neue"/>
-                        </a:rPr>
-                        <a:t>баллов</a:t>
-                      </a:r>
-                      <a:r>
-                        <a:rPr sz="1125" b="0" dirty="0">
-                          <a:solidFill>
-                            <a:srgbClr val="5F5F5F"/>
-                          </a:solidFill>
-                          <a:latin typeface="Helvetica Neue"/>
-                          <a:ea typeface="Helvetica Neue"/>
-                          <a:cs typeface="Helvetica Neue"/>
-                        </a:rPr>
-                        <a:t> </a:t>
-                      </a:r>
-                      <a:r>
-                        <a:rPr sz="1125" b="0" dirty="0" err="1">
-                          <a:solidFill>
-                            <a:srgbClr val="5F5F5F"/>
-                          </a:solidFill>
-                          <a:latin typeface="Helvetica Neue"/>
-                          <a:ea typeface="Helvetica Neue"/>
-                          <a:cs typeface="Helvetica Neue"/>
-                        </a:rPr>
-                        <a:t>к</a:t>
-                      </a:r>
-                      <a:r>
-                        <a:rPr sz="1125" b="0" dirty="0">
-                          <a:solidFill>
-                            <a:srgbClr val="5F5F5F"/>
-                          </a:solidFill>
-                          <a:latin typeface="Helvetica Neue"/>
-                          <a:ea typeface="Helvetica Neue"/>
-                          <a:cs typeface="Helvetica Neue"/>
-                        </a:rPr>
-                        <a:t> 31.12.2026.</a:t>
-                      </a:r>
-                    </a:p>
-                  </a:txBody>
-                  <a:tcPr marL="114300" marR="114300" marT="123825" marB="123825">
-                    <a:lnL w="0">
-                      <a:noFill/>
-                    </a:lnL>
-                    <a:lnR w="0">
-                      <a:noFill/>
-                    </a:lnR>
-                    <a:lnT w="9525" cap="flat" cmpd="sng" algn="ctr">
-                      <a:solidFill>
-                        <a:srgbClr val="EDEDED"/>
-                      </a:solidFill>
-                      <a:prstDash val="solid"/>
-                      <a:round/>
-                      <a:headEnd type="none" w="med" len="med"/>
-                      <a:tailEnd type="none" w="med" len="med"/>
-                    </a:lnT>
-                    <a:lnB w="9525">
-                      <a:solidFill>
-                        <a:srgbClr val="EDEDED"/>
-                      </a:solidFill>
-                    </a:lnB>
-                    <a:solidFill>
-                      <a:srgbClr val="FFFFFF"/>
-                    </a:solidFill>
-                  </a:tcPr>
-                </a:tc>
-                <a:extLst>
-                  <a:ext uri="{0D108BD9-81ED-4DB2-BD59-A6C34878D82A}">
-                    <a16:rowId xmlns:a16="http://schemas.microsoft.com/office/drawing/2014/main" val="10002"/>
-                  </a:ext>
-                </a:extLst>
-              </a:tr>
-            </a:tbl>
-          </a:graphicData>
-        </a:graphic>
-      </p:graphicFrame>
-      <p:sp>
-        <p:nvSpPr>
-          <p:cNvPr id="17" name="instruction">
-            <a:extLst>
-              <a:ext uri="{FF2B5EF4-FFF2-40B4-BE49-F238E27FC236}">
-                <a16:creationId xmlns:a16="http://schemas.microsoft.com/office/drawing/2014/main" id="{066B7228-B225-4154-B3F6-79BBD02070B5}"/>
-              </a:ext>
-            </a:extLst>
-          </p:cNvPr>
-          <p:cNvSpPr>
-            <a:spLocks noGrp="1"/>
-          </p:cNvSpPr>
-          <p:nvPr/>
-        </p:nvSpPr>
-        <p:spPr>
-          <a:xfrm>
-            <a:off x="457200" y="5381625"/>
-            <a:ext cx="11277600" cy="400050"/>
-          </a:xfrm>
-          <a:prstGeom prst="rect">
-            <a:avLst/>
-          </a:prstGeom>
-          <a:noFill/>
-          <a:ln w="0">
-            <a:noFill/>
-          </a:ln>
-        </p:spPr>
-        <p:txBody>
-          <a:bodyPr wrap="square" lIns="0" tIns="0" rIns="0" bIns="0" anchor="t">
-            <a:noAutofit/>
-          </a:bodyPr>
-          <a:lstStyle/>
-          <a:p>
-            <a:pPr algn="l">
-              <a:defRPr sz="1050" b="0">
-                <a:solidFill>
-                  <a:srgbClr val="5F5F5F"/>
-                </a:solidFill>
-                <a:latin typeface="Helvetica Neue"/>
-                <a:ea typeface="Helvetica Neue"/>
-                <a:cs typeface="Helvetica Neue"/>
-              </a:defRPr>
-            </a:pPr>
-            <a:r>
-              <a:rPr sz="1050" b="0">
-                <a:solidFill>
-                  <a:srgbClr val="5F5F5F"/>
-                </a:solidFill>
-                <a:latin typeface="Helvetica Neue"/>
-                <a:ea typeface="Helvetica Neue"/>
-                <a:cs typeface="Helvetica Neue"/>
-              </a:rPr>
-              <a:t>Это один из вариантов подачи. Команда может рассказать о направлении иначе, сохранив продукты и цели.</a:t>
-            </a:r>
-          </a:p>
-        </p:txBody>
-      </p:sp>
-    </p:spTree>
-    <p:extLst>
-      <p:ext uri="{BB962C8B-B14F-4D97-AF65-F5344CB8AC3E}">
-        <p14:creationId xmlns:p14="http://schemas.microsoft.com/office/powerpoint/2010/main" val="395856596"/>
       </p:ext>
     </p:extLst>
   </p:cSld>

</xml_diff>

<commit_message>
feat: name the direction as the Telecom digital experience platform
Translate Telecom Digital Experience Platform and lead the direction slide with the customer-path sentence.

Co-authored-by: bbenicore <bbenicore@gmail.com>
</commit_message>
<xml_diff>
--- a/presentations/Квартальное_демо_Телеком_19.10.2026.pptx
+++ b/presentations/Квартальное_демо_Телеком_19.10.2026.pptx
@@ -1803,7 +1803,7 @@
                 <a:ea typeface="Helvetica Neue"/>
                 <a:cs typeface="Helvetica Neue"/>
               </a:rPr>
-              <a:t>Телеком</a:t>
+              <a:t>Цифровая платформа клиентского опыта Телеком</a:t>
             </a:r>
             <a:r>
               <a:rPr sz="3300" b="1" dirty="0">
@@ -18284,7 +18284,7 @@
                 <a:ea typeface="Helvetica Neue"/>
                 <a:cs typeface="Helvetica Neue"/>
               </a:rPr>
-              <a:t>Телеком · Продуктовое направление</a:t>
+              <a:t>Цифровая платформа клиентского опыта Телеком · Продуктовое направление</a:t>
             </a:r>
           </a:p>
         </p:txBody>
@@ -18398,7 +18398,7 @@
                 <a:ea typeface="Helvetica Neue"/>
                 <a:cs typeface="Helvetica Neue"/>
               </a:rPr>
-              <a:t>Телеком</a:t>
+              <a:t>Цифровая платформа клиентского опыта Телеком</a:t>
             </a:r>
           </a:p>
         </p:txBody>
@@ -18663,7 +18663,7 @@
                 <a:ea typeface="Helvetica Neue"/>
                 <a:cs typeface="Helvetica Neue"/>
               </a:rPr>
-              <a:t>Портфель «Мега5G»: витрина в приложении и лендинг на сайте. Дом групповых продуктов: семейная платформа МегаСемья 2.0, персональные роли для номеров близких. Единый заказ СИМ: обновленные сценарии заказа на MegaFon.ru, MNP и SIM.</a:t>
+              <a:t>Цифровая среда пути клиента: найти, понять, выбрать, купить, подключить и обслуживать. Портфель «Мега5G»: витрина в приложении и лендинг на сайте. Дом групповых продуктов: семейная платформа МегаСемья 2.0, персональные роли для номеров близких. Единый заказ СИМ: обновленные сценарии заказа на MegaFon.ru, MNP и SIM.</a:t>
             </a:r>
           </a:p>
         </p:txBody>
@@ -19541,7 +19541,7 @@
                 <a:ea typeface="Helvetica Neue"/>
                 <a:cs typeface="Helvetica Neue"/>
               </a:rPr>
-              <a:t>Телеком · Метрики Q3–Q4 2026</a:t>
+              <a:t>Цифровая платформа клиентского опыта Телеком · Метрики Q3–Q4 2026</a:t>
             </a:r>
           </a:p>
         </p:txBody>
@@ -22172,7 +22172,7 @@
                 <a:ea typeface="Helvetica Neue"/>
                 <a:cs typeface="Helvetica Neue"/>
               </a:rPr>
-              <a:t>Телеком · Результаты Q3 2026</a:t>
+              <a:t>Цифровая платформа клиентского опыта Телеком · Результаты Q3 2026</a:t>
             </a:r>
           </a:p>
         </p:txBody>
@@ -23699,7 +23699,7 @@
                 <a:ea typeface="Helvetica Neue"/>
                 <a:cs typeface="Helvetica Neue"/>
               </a:rPr>
-              <a:t>Телеком · Демо Q3</a:t>
+              <a:t>Цифровая платформа клиентского опыта Телеком · Демо Q3</a:t>
             </a:r>
           </a:p>
         </p:txBody>
@@ -24170,7 +24170,7 @@
                 <a:ea typeface="Helvetica Neue"/>
                 <a:cs typeface="Helvetica Neue"/>
               </a:rPr>
-              <a:t>Телеком · Демо Q3</a:t>
+              <a:t>Цифровая платформа клиентского опыта Телеком · Демо Q3</a:t>
             </a:r>
           </a:p>
         </p:txBody>
@@ -24641,7 +24641,7 @@
                 <a:ea typeface="Helvetica Neue"/>
                 <a:cs typeface="Helvetica Neue"/>
               </a:rPr>
-              <a:t>Телеком · Демо Q3</a:t>
+              <a:t>Цифровая платформа клиентского опыта Телеком · Демо Q3</a:t>
             </a:r>
           </a:p>
         </p:txBody>
@@ -25079,7 +25079,7 @@
                 <a:ea typeface="Helvetica Neue"/>
                 <a:cs typeface="Helvetica Neue"/>
               </a:rPr>
-              <a:t>Телеком · Планы Q4 2026</a:t>
+              <a:t>Цифровая платформа клиентского опыта Телеком · Планы Q4 2026</a:t>
             </a:r>
           </a:p>
         </p:txBody>

</xml_diff>

<commit_message>
feat: add the group-products house launches to the Q4 plan
The source dates those migrations across 2027, so the row keeps 1Q27 through 4Q27.

Co-authored-by: bbenicore <bbenicore@gmail.com>
</commit_message>
<xml_diff>
--- a/presentations/Квартальное_демо_Телеком_19.10.2026.pptx
+++ b/presentations/Квартальное_демо_Телеком_19.10.2026.pptx
@@ -25422,7 +25422,7 @@
         </p:nvGraphicFramePr>
         <p:xfrm>
           <a:off x="457200" y="1752600"/>
-          <a:ext cx="11277600" cy="2380000"/>
+          <a:ext cx="11277600" cy="2880000"/>
         </p:xfrm>
         <a:graphic>
           <a:graphicData uri="http://schemas.openxmlformats.org/drawingml/2006/table">
@@ -25669,7 +25669,7 @@
                   </a:ext>
                 </a:extLst>
               </a:tr>
-              <a:tr h="980000">
+              <a:tr h="700000">
                 <a:tc>
                   <a:txBody>
                     <a:bodyPr/>
@@ -25920,7 +25920,258 @@
                   </a:ext>
                 </a:extLst>
               </a:tr>
-              <a:tr h="980000">
+              <a:tr h="1000000">
+                <a:tc>
+                  <a:txBody>
+                    <a:bodyPr/>
+                    <a:lstStyle/>
+                    <a:p>
+                      <a:pPr algn="l">
+                        <a:lnSpc>
+                          <a:spcPts val="1575"/>
+                        </a:lnSpc>
+                        <a:spcBef>
+                          <a:spcPts val="0"/>
+                        </a:spcBef>
+                        <a:spcAft>
+                          <a:spcPts val="0"/>
+                        </a:spcAft>
+                      </a:pPr>
+                      <a:r>
+                        <a:rPr sz="1125" b="0">
+                          <a:solidFill>
+                            <a:srgbClr val="333333"/>
+                          </a:solidFill>
+                          <a:latin typeface="Helvetica Neue"/>
+                          <a:ea typeface="Helvetica Neue"/>
+                          <a:cs typeface="Helvetica Neue"/>
+                        </a:rPr>
+                        <a:t>Продуктовый</a:t>
+                      </a:r>
+                    </a:p>
+                    <a:p>
+                      <a:pPr algn="l">
+                        <a:lnSpc>
+                          <a:spcPts val="1575"/>
+                        </a:lnSpc>
+                        <a:spcBef>
+                          <a:spcPts val="0"/>
+                        </a:spcBef>
+                        <a:spcAft>
+                          <a:spcPts val="0"/>
+                        </a:spcAft>
+                      </a:pPr>
+                      <a:r>
+                        <a:rPr sz="1125" b="0">
+                          <a:solidFill>
+                            <a:srgbClr val="333333"/>
+                          </a:solidFill>
+                          <a:latin typeface="Helvetica Neue"/>
+                          <a:ea typeface="Helvetica Neue"/>
+                          <a:cs typeface="Helvetica Neue"/>
+                        </a:rPr>
+                        <a:t>Дом групповых продуктов</a:t>
+                      </a:r>
+                    </a:p>
+                  </a:txBody>
+                  <a:tcPr marL="114300" marR="114300" marT="123825" marB="123825">
+                    <a:lnL w="0">
+                      <a:noFill/>
+                    </a:lnL>
+                    <a:lnR w="0">
+                      <a:noFill/>
+                    </a:lnR>
+                    <a:lnT w="9525" cap="flat" cmpd="sng" algn="ctr">
+                      <a:solidFill>
+                        <a:srgbClr val="EDEDED"/>
+                      </a:solidFill>
+                      <a:prstDash val="solid"/>
+                      <a:round/>
+                      <a:headEnd type="none" w="med" len="med"/>
+                      <a:tailEnd type="none" w="med" len="med"/>
+                    </a:lnT>
+                    <a:lnB w="9525">
+                      <a:solidFill>
+                        <a:srgbClr val="EDEDED"/>
+                      </a:solidFill>
+                    </a:lnB>
+                    <a:solidFill>
+                      <a:srgbClr val="FFFFFF"/>
+                    </a:solidFill>
+                  </a:tcPr>
+                </a:tc>
+                <a:tc>
+                  <a:txBody>
+                    <a:bodyPr/>
+                    <a:lstStyle/>
+                    <a:p>
+                      <a:pPr algn="l">
+                        <a:lnSpc>
+                          <a:spcPts val="1575"/>
+                        </a:lnSpc>
+                        <a:spcBef>
+                          <a:spcPts val="0"/>
+                        </a:spcBef>
+                        <a:spcAft>
+                          <a:spcPts val="0"/>
+                        </a:spcAft>
+                      </a:pPr>
+                      <a:r>
+                        <a:rPr sz="1125" b="0">
+                          <a:solidFill>
+                            <a:srgbClr val="666666"/>
+                          </a:solidFill>
+                          <a:latin typeface="Helvetica Neue"/>
+                          <a:ea typeface="Helvetica Neue"/>
+                          <a:cs typeface="Helvetica Neue"/>
+                        </a:rPr>
+                        <a:t>1Q27 – миграция Дели тариф. 2Q27 – миграция Плати за близких. 3Q27 – миграция Семейной безопасности. 4Q27 – миграция Контроля аккаунтов.</a:t>
+                      </a:r>
+                    </a:p>
+                  </a:txBody>
+                  <a:tcPr marL="114300" marR="114300" marT="123825" marB="123825">
+                    <a:lnL w="0">
+                      <a:noFill/>
+                    </a:lnL>
+                    <a:lnR w="0">
+                      <a:noFill/>
+                    </a:lnR>
+                    <a:lnT w="9525" cap="flat" cmpd="sng" algn="ctr">
+                      <a:solidFill>
+                        <a:srgbClr val="EDEDED"/>
+                      </a:solidFill>
+                      <a:prstDash val="solid"/>
+                      <a:round/>
+                      <a:headEnd type="none" w="med" len="med"/>
+                      <a:tailEnd type="none" w="med" len="med"/>
+                    </a:lnT>
+                    <a:lnB w="9525">
+                      <a:solidFill>
+                        <a:srgbClr val="EDEDED"/>
+                      </a:solidFill>
+                    </a:lnB>
+                    <a:solidFill>
+                      <a:srgbClr val="FFFFFF"/>
+                    </a:solidFill>
+                  </a:tcPr>
+                </a:tc>
+                <a:tc>
+                  <a:txBody>
+                    <a:bodyPr/>
+                    <a:lstStyle/>
+                    <a:p>
+                      <a:pPr algn="l">
+                        <a:lnSpc>
+                          <a:spcPts val="1575"/>
+                        </a:lnSpc>
+                        <a:spcBef>
+                          <a:spcPts val="0"/>
+                        </a:spcBef>
+                        <a:spcAft>
+                          <a:spcPts val="0"/>
+                        </a:spcAft>
+                      </a:pPr>
+                      <a:r>
+                        <a:rPr sz="1125" b="0">
+                          <a:solidFill>
+                            <a:srgbClr val="666666"/>
+                          </a:solidFill>
+                          <a:latin typeface="Helvetica Neue"/>
+                          <a:ea typeface="Helvetica Neue"/>
+                          <a:cs typeface="Helvetica Neue"/>
+                        </a:rPr>
+                        <a:t/>
+                      </a:r>
+                    </a:p>
+                  </a:txBody>
+                  <a:tcPr marL="114300" marR="114300" marT="123825" marB="123825">
+                    <a:lnL w="0">
+                      <a:noFill/>
+                    </a:lnL>
+                    <a:lnR w="0">
+                      <a:noFill/>
+                    </a:lnR>
+                    <a:lnT w="9525" cap="flat" cmpd="sng" algn="ctr">
+                      <a:solidFill>
+                        <a:srgbClr val="EDEDED"/>
+                      </a:solidFill>
+                      <a:prstDash val="solid"/>
+                      <a:round/>
+                      <a:headEnd type="none" w="med" len="med"/>
+                      <a:tailEnd type="none" w="med" len="med"/>
+                    </a:lnT>
+                    <a:lnB w="9525">
+                      <a:solidFill>
+                        <a:srgbClr val="EDEDED"/>
+                      </a:solidFill>
+                    </a:lnB>
+                    <a:solidFill>
+                      <a:srgbClr val="FFFFFF"/>
+                    </a:solidFill>
+                  </a:tcPr>
+                </a:tc>
+                <a:tc>
+                  <a:txBody>
+                    <a:bodyPr/>
+                    <a:lstStyle/>
+                    <a:p>
+                      <a:pPr algn="l">
+                        <a:lnSpc>
+                          <a:spcPts val="1575"/>
+                        </a:lnSpc>
+                        <a:spcBef>
+                          <a:spcPts val="0"/>
+                        </a:spcBef>
+                        <a:spcAft>
+                          <a:spcPts val="0"/>
+                        </a:spcAft>
+                      </a:pPr>
+                      <a:r>
+                        <a:rPr sz="1125" b="0">
+                          <a:solidFill>
+                            <a:srgbClr val="666666"/>
+                          </a:solidFill>
+                          <a:latin typeface="Helvetica Neue"/>
+                          <a:ea typeface="Helvetica Neue"/>
+                          <a:cs typeface="Helvetica Neue"/>
+                        </a:rPr>
+                        <a:t>1Q27–4Q27</a:t>
+                      </a:r>
+                    </a:p>
+                  </a:txBody>
+                  <a:tcPr marL="114300" marR="114300" marT="123825" marB="123825">
+                    <a:lnL w="0">
+                      <a:noFill/>
+                    </a:lnL>
+                    <a:lnR w="0">
+                      <a:noFill/>
+                    </a:lnR>
+                    <a:lnT w="9525" cap="flat" cmpd="sng" algn="ctr">
+                      <a:solidFill>
+                        <a:srgbClr val="EDEDED"/>
+                      </a:solidFill>
+                      <a:prstDash val="solid"/>
+                      <a:round/>
+                      <a:headEnd type="none" w="med" len="med"/>
+                      <a:tailEnd type="none" w="med" len="med"/>
+                    </a:lnT>
+                    <a:lnB w="9525">
+                      <a:solidFill>
+                        <a:srgbClr val="EDEDED"/>
+                      </a:solidFill>
+                    </a:lnB>
+                    <a:solidFill>
+                      <a:srgbClr val="FFFFFF"/>
+                    </a:solidFill>
+                  </a:tcPr>
+                </a:tc>
+                <a:extLst>
+                  <a:ext uri="{0D108BD9-81ED-4DB2-BD59-A6C34878D82A}">
+                    <a16:rowId xmlns:a16="http://schemas.microsoft.com/office/drawing/2014/main" val="10001"/>
+                  </a:ext>
+                </a:extLst>
+              </a:tr>
+              <a:tr h="760000">
                 <a:tc>
                   <a:txBody>
                     <a:bodyPr/>

</xml_diff>